<commit_message>
docs: rebuild the 3-slide CI/CD brief around visuals, add speaking script
- NextStep-CICD-Brief.pptx: cut from ~430 words to 171 and replaced the
  prose with 13 custom line-art graphics — a pipeline illustration on the
  title slide, icon rows for the CI and CD lanes, and a Gate/Publish/
  Deploy flow showing two green and one paused.
- CICD-Presentation-Script.md: word-for-word script per slide with
  timings, plus prepared answers for the likely questions. Same text is
  in each slide's speaker notes.

Co-Authored-By: Claude Opus 5 <noreply@anthropic.com>
</commit_message>
<xml_diff>
--- a/docs/NextStep-CICD-Brief.pptx
+++ b/docs/NextStep-CICD-Brief.pptx
@@ -504,7 +504,7 @@
           <a:lstStyle/>
           <a:p>
             <a:r>
-              <a:t>One-liner opener: my contribution this phase was the CI/CD pipeline. Before this, checking that the app still worked was manual and depended on whose laptop ran it, and the API tests were being skipped because they need a seeded database. Now GitHub Actions does it on every commit. Two pipelines, seven jobs.</a:t>
+              <a:t>SLIDE 1 (about 40 seconds). My part of the project this phase was the CI/CD pipeline. The diagram on the right is the flow: a commit comes in, it gets tested, it gets packaged into a Docker image, and the last step, releasing it to a server, is greyed out because that is the part still waiting. Two pipelines, seven jobs, seventeen tests, two container images — all of it runs by itself on GitHub Actions.</a:t>
             </a:r>
           </a:p>
         </p:txBody>
@@ -574,7 +574,7 @@
           <a:lstStyle/>
           <a:p>
             <a:r>
-              <a:t>Walk the top row left to right, then the bottom row. The point to land: CI answers 'is this correct', CD answers 'how does it reach users' — and CD's first job re-runs all of CI, so nothing untested can ever be published. If asked what was hardest: the tests import the real controllers, which query Postgres, so CI starts a disposable postgres:16 container, waits for it to be ready, runs db:init to create the schema and seed data, then the tests. That needed one code change — SSL was hard-coded on for Supabase, so I made it a DATABASE_SSL toggle: on for Supabase, off for the CI container.</a:t>
+              <a:t>SLIDE 2 (about 60 seconds). Top row is CI, and it runs on every single push. Quality checks that no secrets got committed. Tests spin up a real PostgreSQL database and run seventeen tests. Build compiles the production frontend. Image builds both containers. Bottom row is CD, on every merge into main. The gate re-runs all of CI first, publish pushes both images to GitHub's registry tagged with the commit, and release is behind an approval click. The line at the bottom is the point: a failing test turns the pull request red, so broken code cannot be merged.</a:t>
             </a:r>
           </a:p>
         </p:txBody>
@@ -644,7 +644,7 @@
           <a:lstStyle/>
           <a:p>
             <a:r>
-              <a:t>Be upfront about the gap — it earns more credit than overclaiming. The deploy mechanism is written and reviewable; what it is waiting for is a server, not more code. Same with lint: leaving it out was a decision, not an oversight. End on the one-sentence version, which is also the answer to 'so do you have CI/CD or not?'</a:t>
+              <a:t>SLIDE 3 (about 40 seconds). Three things are live: CI on every push, tests against a real database, and images published on every merge. The fourth is honest — we have no server yet, so the deploy job detects that and skips instead of failing. The diagram shows it: two green, one paused. Finish on the sentence in the box, which is also the answer if you are asked whether we have CI/CD.</a:t>
             </a:r>
           </a:p>
         </p:txBody>
@@ -3660,20 +3660,201 @@
       <p:grpSpPr/>
       <p:sp>
         <p:nvSpPr>
-          <p:cNvPr id="2" name="Oval 1"/>
+          <p:cNvPr id="2" name="TextBox 1"/>
+          <p:cNvSpPr txBox="1"/>
+          <p:nvPr/>
+        </p:nvSpPr>
+        <p:spPr>
+          <a:xfrm>
+            <a:off x="640080" y="256032"/>
+            <a:ext cx="6858000" cy="219456"/>
+          </a:xfrm>
+          <a:prstGeom prst="rect">
+            <a:avLst/>
+          </a:prstGeom>
+          <a:noFill/>
+        </p:spPr>
+        <p:txBody>
+          <a:bodyPr wrap="square" lIns="0" rIns="0" tIns="0" bIns="0">
+            <a:spAutoFit/>
+          </a:bodyPr>
+          <a:lstStyle/>
+          <a:p>
+            <a:pPr algn="l">
+              <a:spcAft>
+                <a:spcPts val="0"/>
+              </a:spcAft>
+            </a:pPr>
+            <a:r>
+              <a:rPr sz="1100" b="1" i="0" spc="160">
+                <a:solidFill>
+                  <a:srgbClr val="02C39A"/>
+                </a:solidFill>
+                <a:latin typeface="Calibri"/>
+              </a:rPr>
+              <a:t>C270 DEVOPS ESSENTIALS  ·  HPONE DEPAR</a:t>
+            </a:r>
+          </a:p>
+        </p:txBody>
+      </p:sp>
+      <p:pic>
+        <p:nvPicPr>
+          <p:cNvPr id="3" name="Picture 2" descr="hero_pipeline.png"/>
+          <p:cNvPicPr>
+            <a:picLocks noChangeAspect="1"/>
+          </p:cNvPicPr>
+          <p:nvPr/>
+        </p:nvPicPr>
+        <p:blipFill>
+          <a:blip r:embed="rId2"/>
+          <a:stretch>
+            <a:fillRect/>
+          </a:stretch>
+        </p:blipFill>
+        <p:spPr>
+          <a:xfrm>
+            <a:off x="8183879" y="822960"/>
+            <a:ext cx="2859329" cy="5394960"/>
+          </a:xfrm>
+          <a:prstGeom prst="rect">
+            <a:avLst/>
+          </a:prstGeom>
+        </p:spPr>
+      </p:pic>
+      <p:sp>
+        <p:nvSpPr>
+          <p:cNvPr id="4" name="TextBox 3"/>
+          <p:cNvSpPr txBox="1"/>
+          <p:nvPr/>
+        </p:nvSpPr>
+        <p:spPr>
+          <a:xfrm>
+            <a:off x="640080" y="1600200"/>
+            <a:ext cx="6949440" cy="2011680"/>
+          </a:xfrm>
+          <a:prstGeom prst="rect">
+            <a:avLst/>
+          </a:prstGeom>
+          <a:noFill/>
+        </p:spPr>
+        <p:txBody>
+          <a:bodyPr wrap="square" lIns="0" rIns="0" tIns="0" bIns="0">
+            <a:spAutoFit/>
+          </a:bodyPr>
+          <a:lstStyle/>
+          <a:p>
+            <a:pPr algn="l">
+              <a:spcAft>
+                <a:spcPts val="200"/>
+              </a:spcAft>
+            </a:pPr>
+            <a:r>
+              <a:rPr sz="5600" b="1" i="0">
+                <a:solidFill>
+                  <a:srgbClr val="FFFFFF"/>
+                </a:solidFill>
+                <a:latin typeface="Cambria"/>
+              </a:rPr>
+              <a:t>CI/CD Pipeline</a:t>
+            </a:r>
+          </a:p>
+          <a:p>
+            <a:pPr algn="l">
+              <a:spcAft>
+                <a:spcPts val="0"/>
+              </a:spcAft>
+            </a:pPr>
+            <a:r>
+              <a:rPr sz="3000" b="0" i="0">
+                <a:solidFill>
+                  <a:srgbClr val="9FD9E8"/>
+                </a:solidFill>
+                <a:latin typeface="Cambria"/>
+              </a:rPr>
+              <a:t>for NextStep</a:t>
+            </a:r>
+          </a:p>
+        </p:txBody>
+      </p:sp>
+      <p:sp>
+        <p:nvSpPr>
+          <p:cNvPr id="5" name="TextBox 4"/>
+          <p:cNvSpPr txBox="1"/>
+          <p:nvPr/>
+        </p:nvSpPr>
+        <p:spPr>
+          <a:xfrm>
+            <a:off x="640080" y="3703320"/>
+            <a:ext cx="6766560" cy="868680"/>
+          </a:xfrm>
+          <a:prstGeom prst="rect">
+            <a:avLst/>
+          </a:prstGeom>
+          <a:noFill/>
+        </p:spPr>
+        <p:txBody>
+          <a:bodyPr wrap="square" lIns="0" rIns="0" tIns="0" bIns="0">
+            <a:spAutoFit/>
+          </a:bodyPr>
+          <a:lstStyle/>
+          <a:p>
+            <a:pPr algn="l">
+              <a:lnSpc>
+                <a:spcPct val="110000"/>
+              </a:lnSpc>
+              <a:spcAft>
+                <a:spcPts val="500"/>
+              </a:spcAft>
+            </a:pPr>
+            <a:r>
+              <a:rPr sz="2100" b="1" i="0">
+                <a:solidFill>
+                  <a:srgbClr val="02C39A"/>
+                </a:solidFill>
+                <a:latin typeface="Calibri"/>
+              </a:rPr>
+              <a:t>Every commit tested.</a:t>
+            </a:r>
+          </a:p>
+          <a:p>
+            <a:pPr algn="l">
+              <a:lnSpc>
+                <a:spcPct val="110000"/>
+              </a:lnSpc>
+              <a:spcAft>
+                <a:spcPts val="0"/>
+              </a:spcAft>
+            </a:pPr>
+            <a:r>
+              <a:rPr sz="2100" b="1" i="0">
+                <a:solidFill>
+                  <a:srgbClr val="02C39A"/>
+                </a:solidFill>
+                <a:latin typeface="Calibri"/>
+              </a:rPr>
+              <a:t>Every merge packaged.</a:t>
+            </a:r>
+          </a:p>
+        </p:txBody>
+      </p:sp>
+      <p:sp>
+        <p:nvSpPr>
+          <p:cNvPr id="6" name="Rounded Rectangle 5"/>
           <p:cNvSpPr/>
           <p:nvPr/>
         </p:nvSpPr>
         <p:spPr>
           <a:xfrm>
-            <a:off x="640080" y="914400"/>
-            <a:ext cx="566928" cy="566928"/>
-          </a:xfrm>
-          <a:prstGeom prst="ellipse">
-            <a:avLst/>
+            <a:off x="640080" y="4892040"/>
+            <a:ext cx="1572768" cy="960120"/>
+          </a:xfrm>
+          <a:prstGeom prst="roundRect">
+            <a:avLst>
+              <a:gd name="adj" fmla="val 6000"/>
+            </a:avLst>
           </a:prstGeom>
           <a:solidFill>
-            <a:srgbClr val="02C39A"/>
+            <a:srgbClr val="2E396E"/>
           </a:solidFill>
           <a:ln>
             <a:noFill/>
@@ -3695,42 +3876,7 @@
           </a:fontRef>
         </p:style>
         <p:txBody>
-          <a:bodyPr rtlCol="0" anchor="ctr" lIns="0" rIns="0" tIns="0" bIns="0"/>
-          <a:lstStyle/>
-          <a:p>
-            <a:pPr algn="ctr"/>
-            <a:r>
-              <a:rPr sz="2200" b="1">
-                <a:solidFill>
-                  <a:srgbClr val="21295C"/>
-                </a:solidFill>
-                <a:latin typeface="Calibri"/>
-              </a:rPr>
-              <a:t>✓</a:t>
-            </a:r>
-          </a:p>
-        </p:txBody>
-      </p:sp>
-      <p:sp>
-        <p:nvSpPr>
-          <p:cNvPr id="3" name="TextBox 2"/>
-          <p:cNvSpPr txBox="1"/>
-          <p:nvPr/>
-        </p:nvSpPr>
-        <p:spPr>
-          <a:xfrm>
-            <a:off x="1417319" y="978408"/>
-            <a:ext cx="8229600" cy="365760"/>
-          </a:xfrm>
-          <a:prstGeom prst="rect">
-            <a:avLst/>
-          </a:prstGeom>
-          <a:noFill/>
-        </p:spPr>
-        <p:txBody>
-          <a:bodyPr wrap="square" lIns="0" rIns="0" tIns="0" bIns="0">
-            <a:spAutoFit/>
-          </a:bodyPr>
+          <a:bodyPr rtlCol="0" anchor="ctr" wrap="square" lIns="128016" rIns="128016" tIns="137160" bIns="137160"/>
           <a:lstStyle/>
           <a:p>
             <a:pPr algn="l">
@@ -3739,52 +3885,13 @@
               </a:spcAft>
             </a:pPr>
             <a:r>
-              <a:rPr sz="1200" b="1" i="0">
+              <a:rPr sz="2600" b="1" i="0">
                 <a:solidFill>
                   <a:srgbClr val="02C39A"/>
                 </a:solidFill>
-                <a:latin typeface="Calibri"/>
-              </a:rPr>
-              <a:t>C270 DEVOPS ESSENTIALS  ·  MY CONTRIBUTION THIS PHASE</a:t>
-            </a:r>
-          </a:p>
-        </p:txBody>
-      </p:sp>
-      <p:sp>
-        <p:nvSpPr>
-          <p:cNvPr id="4" name="TextBox 3"/>
-          <p:cNvSpPr txBox="1"/>
-          <p:nvPr/>
-        </p:nvSpPr>
-        <p:spPr>
-          <a:xfrm>
-            <a:off x="640080" y="1783080"/>
-            <a:ext cx="10058400" cy="1737360"/>
-          </a:xfrm>
-          <a:prstGeom prst="rect">
-            <a:avLst/>
-          </a:prstGeom>
-          <a:noFill/>
-        </p:spPr>
-        <p:txBody>
-          <a:bodyPr wrap="square" lIns="0" rIns="0" tIns="0" bIns="0">
-            <a:spAutoFit/>
-          </a:bodyPr>
-          <a:lstStyle/>
-          <a:p>
-            <a:pPr algn="l">
-              <a:spcAft>
-                <a:spcPts val="200"/>
-              </a:spcAft>
-            </a:pPr>
-            <a:r>
-              <a:rPr sz="4000" b="1" i="0">
-                <a:solidFill>
-                  <a:srgbClr val="FFFFFF"/>
-                </a:solidFill>
                 <a:latin typeface="Cambria"/>
               </a:rPr>
-              <a:t>I automated NextStep's build,</a:t>
+              <a:t>2</a:t>
             </a:r>
           </a:p>
           <a:p>
@@ -3794,69 +3901,27 @@
               </a:spcAft>
             </a:pPr>
             <a:r>
-              <a:rPr sz="4000" b="1" i="0">
-                <a:solidFill>
-                  <a:srgbClr val="9FD9E8"/>
-                </a:solidFill>
-                <a:latin typeface="Cambria"/>
-              </a:rPr>
-              <a:t>test and release process</a:t>
-            </a:r>
-          </a:p>
-        </p:txBody>
-      </p:sp>
-      <p:sp>
-        <p:nvSpPr>
-          <p:cNvPr id="5" name="TextBox 4"/>
-          <p:cNvSpPr txBox="1"/>
-          <p:nvPr/>
-        </p:nvSpPr>
-        <p:spPr>
-          <a:xfrm>
-            <a:off x="640080" y="3703320"/>
-            <a:ext cx="10424160" cy="777240"/>
-          </a:xfrm>
-          <a:prstGeom prst="rect">
-            <a:avLst/>
-          </a:prstGeom>
-          <a:noFill/>
-        </p:spPr>
-        <p:txBody>
-          <a:bodyPr wrap="square" lIns="0" rIns="0" tIns="0" bIns="0">
-            <a:spAutoFit/>
-          </a:bodyPr>
-          <a:lstStyle/>
-          <a:p>
-            <a:pPr algn="l">
-              <a:lnSpc>
-                <a:spcPct val="120000"/>
-              </a:lnSpc>
-              <a:spcAft>
-                <a:spcPts val="0"/>
-              </a:spcAft>
-            </a:pPr>
-            <a:r>
-              <a:rPr sz="1600" b="0" i="0">
+              <a:rPr sz="1150" b="0" i="0">
                 <a:solidFill>
                   <a:srgbClr val="C5D5E0"/>
                 </a:solidFill>
                 <a:latin typeface="Calibri"/>
               </a:rPr>
-              <a:t>Two GitHub Actions pipelines now run on their own: one verifies every commit, the other packages and releases it.</a:t>
-            </a:r>
-          </a:p>
-        </p:txBody>
-      </p:sp>
-      <p:sp>
-        <p:nvSpPr>
-          <p:cNvPr id="6" name="Rounded Rectangle 5"/>
+              <a:t>pipelines</a:t>
+            </a:r>
+          </a:p>
+        </p:txBody>
+      </p:sp>
+      <p:sp>
+        <p:nvSpPr>
+          <p:cNvPr id="7" name="Rounded Rectangle 6"/>
           <p:cNvSpPr/>
           <p:nvPr/>
         </p:nvSpPr>
         <p:spPr>
           <a:xfrm>
-            <a:off x="640080" y="4709160"/>
-            <a:ext cx="2551176" cy="1051560"/>
+            <a:off x="2350008" y="4892040"/>
+            <a:ext cx="1572768" cy="960120"/>
           </a:xfrm>
           <a:prstGeom prst="roundRect">
             <a:avLst>
@@ -3886,7 +3951,7 @@
           </a:fontRef>
         </p:style>
         <p:txBody>
-          <a:bodyPr rtlCol="0" anchor="ctr" wrap="square" lIns="182880" rIns="182880" tIns="137160" bIns="137160"/>
+          <a:bodyPr rtlCol="0" anchor="ctr" wrap="square" lIns="128016" rIns="128016" tIns="137160" bIns="137160"/>
           <a:lstStyle/>
           <a:p>
             <a:pPr algn="l">
@@ -3895,46 +3960,43 @@
               </a:spcAft>
             </a:pPr>
             <a:r>
-              <a:rPr sz="2800" b="1" i="0">
+              <a:rPr sz="2600" b="1" i="0">
                 <a:solidFill>
                   <a:srgbClr val="02C39A"/>
                 </a:solidFill>
                 <a:latin typeface="Cambria"/>
               </a:rPr>
-              <a:t>2</a:t>
+              <a:t>7</a:t>
             </a:r>
           </a:p>
           <a:p>
             <a:pPr algn="l">
-              <a:lnSpc>
-                <a:spcPct val="105000"/>
-              </a:lnSpc>
               <a:spcAft>
                 <a:spcPts val="0"/>
               </a:spcAft>
             </a:pPr>
             <a:r>
-              <a:rPr sz="1200" b="0" i="0">
+              <a:rPr sz="1150" b="0" i="0">
                 <a:solidFill>
                   <a:srgbClr val="C5D5E0"/>
                 </a:solidFill>
                 <a:latin typeface="Calibri"/>
               </a:rPr>
-              <a:t>pipelines</a:t>
-            </a:r>
-          </a:p>
-        </p:txBody>
-      </p:sp>
-      <p:sp>
-        <p:nvSpPr>
-          <p:cNvPr id="7" name="Rounded Rectangle 6"/>
+              <a:t>jobs</a:t>
+            </a:r>
+          </a:p>
+        </p:txBody>
+      </p:sp>
+      <p:sp>
+        <p:nvSpPr>
+          <p:cNvPr id="8" name="Rounded Rectangle 7"/>
           <p:cNvSpPr/>
           <p:nvPr/>
         </p:nvSpPr>
         <p:spPr>
           <a:xfrm>
-            <a:off x="3291839" y="4709160"/>
-            <a:ext cx="2551176" cy="1051560"/>
+            <a:off x="4059936" y="4892040"/>
+            <a:ext cx="1572768" cy="960120"/>
           </a:xfrm>
           <a:prstGeom prst="roundRect">
             <a:avLst>
@@ -3964,7 +4026,7 @@
           </a:fontRef>
         </p:style>
         <p:txBody>
-          <a:bodyPr rtlCol="0" anchor="ctr" wrap="square" lIns="182880" rIns="182880" tIns="137160" bIns="137160"/>
+          <a:bodyPr rtlCol="0" anchor="ctr" wrap="square" lIns="128016" rIns="128016" tIns="137160" bIns="137160"/>
           <a:lstStyle/>
           <a:p>
             <a:pPr algn="l">
@@ -3973,46 +4035,43 @@
               </a:spcAft>
             </a:pPr>
             <a:r>
-              <a:rPr sz="2800" b="1" i="0">
+              <a:rPr sz="2600" b="1" i="0">
                 <a:solidFill>
                   <a:srgbClr val="02C39A"/>
                 </a:solidFill>
                 <a:latin typeface="Cambria"/>
               </a:rPr>
-              <a:t>7</a:t>
+              <a:t>17</a:t>
             </a:r>
           </a:p>
           <a:p>
             <a:pPr algn="l">
-              <a:lnSpc>
-                <a:spcPct val="105000"/>
-              </a:lnSpc>
               <a:spcAft>
                 <a:spcPts val="0"/>
               </a:spcAft>
             </a:pPr>
             <a:r>
-              <a:rPr sz="1200" b="0" i="0">
+              <a:rPr sz="1150" b="0" i="0">
                 <a:solidFill>
                   <a:srgbClr val="C5D5E0"/>
                 </a:solidFill>
                 <a:latin typeface="Calibri"/>
               </a:rPr>
-              <a:t>automated jobs</a:t>
-            </a:r>
-          </a:p>
-        </p:txBody>
-      </p:sp>
-      <p:sp>
-        <p:nvSpPr>
-          <p:cNvPr id="8" name="Rounded Rectangle 7"/>
+              <a:t>tests</a:t>
+            </a:r>
+          </a:p>
+        </p:txBody>
+      </p:sp>
+      <p:sp>
+        <p:nvSpPr>
+          <p:cNvPr id="9" name="Rounded Rectangle 8"/>
           <p:cNvSpPr/>
           <p:nvPr/>
         </p:nvSpPr>
         <p:spPr>
           <a:xfrm>
-            <a:off x="5943600" y="4709160"/>
-            <a:ext cx="2551176" cy="1051560"/>
+            <a:off x="5769864" y="4892040"/>
+            <a:ext cx="1572768" cy="960120"/>
           </a:xfrm>
           <a:prstGeom prst="roundRect">
             <a:avLst>
@@ -4042,7 +4101,7 @@
           </a:fontRef>
         </p:style>
         <p:txBody>
-          <a:bodyPr rtlCol="0" anchor="ctr" wrap="square" lIns="182880" rIns="182880" tIns="137160" bIns="137160"/>
+          <a:bodyPr rtlCol="0" anchor="ctr" wrap="square" lIns="128016" rIns="128016" tIns="137160" bIns="137160"/>
           <a:lstStyle/>
           <a:p>
             <a:pPr algn="l">
@@ -4051,85 +4110,7 @@
               </a:spcAft>
             </a:pPr>
             <a:r>
-              <a:rPr sz="2800" b="1" i="0">
-                <a:solidFill>
-                  <a:srgbClr val="02C39A"/>
-                </a:solidFill>
-                <a:latin typeface="Cambria"/>
-              </a:rPr>
-              <a:t>17</a:t>
-            </a:r>
-          </a:p>
-          <a:p>
-            <a:pPr algn="l">
-              <a:lnSpc>
-                <a:spcPct val="105000"/>
-              </a:lnSpc>
-              <a:spcAft>
-                <a:spcPts val="0"/>
-              </a:spcAft>
-            </a:pPr>
-            <a:r>
-              <a:rPr sz="1200" b="0" i="0">
-                <a:solidFill>
-                  <a:srgbClr val="C5D5E0"/>
-                </a:solidFill>
-                <a:latin typeface="Calibri"/>
-              </a:rPr>
-              <a:t>tests per run</a:t>
-            </a:r>
-          </a:p>
-        </p:txBody>
-      </p:sp>
-      <p:sp>
-        <p:nvSpPr>
-          <p:cNvPr id="9" name="Rounded Rectangle 8"/>
-          <p:cNvSpPr/>
-          <p:nvPr/>
-        </p:nvSpPr>
-        <p:spPr>
-          <a:xfrm>
-            <a:off x="8595360" y="4709160"/>
-            <a:ext cx="2551176" cy="1051560"/>
-          </a:xfrm>
-          <a:prstGeom prst="roundRect">
-            <a:avLst>
-              <a:gd name="adj" fmla="val 6000"/>
-            </a:avLst>
-          </a:prstGeom>
-          <a:solidFill>
-            <a:srgbClr val="2E396E"/>
-          </a:solidFill>
-          <a:ln>
-            <a:noFill/>
-          </a:ln>
-          <a:effectLst/>
-        </p:spPr>
-        <p:style>
-          <a:lnRef idx="1">
-            <a:schemeClr val="accent1"/>
-          </a:lnRef>
-          <a:fillRef idx="3">
-            <a:schemeClr val="accent1"/>
-          </a:fillRef>
-          <a:effectRef idx="2">
-            <a:schemeClr val="accent1"/>
-          </a:effectRef>
-          <a:fontRef idx="minor">
-            <a:schemeClr val="lt1"/>
-          </a:fontRef>
-        </p:style>
-        <p:txBody>
-          <a:bodyPr rtlCol="0" anchor="ctr" wrap="square" lIns="182880" rIns="182880" tIns="137160" bIns="137160"/>
-          <a:lstStyle/>
-          <a:p>
-            <a:pPr algn="l">
-              <a:spcAft>
-                <a:spcPts val="0"/>
-              </a:spcAft>
-            </a:pPr>
-            <a:r>
-              <a:rPr sz="2800" b="1" i="0">
+              <a:rPr sz="2600" b="1" i="0">
                 <a:solidFill>
                   <a:srgbClr val="02C39A"/>
                 </a:solidFill>
@@ -4140,21 +4121,18 @@
           </a:p>
           <a:p>
             <a:pPr algn="l">
-              <a:lnSpc>
-                <a:spcPct val="105000"/>
-              </a:lnSpc>
               <a:spcAft>
                 <a:spcPts val="0"/>
               </a:spcAft>
             </a:pPr>
             <a:r>
-              <a:rPr sz="1200" b="0" i="0">
+              <a:rPr sz="1150" b="0" i="0">
                 <a:solidFill>
                   <a:srgbClr val="C5D5E0"/>
                 </a:solidFill>
                 <a:latin typeface="Calibri"/>
               </a:rPr>
-              <a:t>Docker images published</a:t>
+              <a:t>images</a:t>
             </a:r>
           </a:p>
         </p:txBody>
@@ -4167,8 +4145,8 @@
         </p:nvSpPr>
         <p:spPr>
           <a:xfrm>
-            <a:off x="640080" y="5989320"/>
-            <a:ext cx="10881360" cy="365760"/>
+            <a:off x="640080" y="6126480"/>
+            <a:ext cx="6949440" cy="274320"/>
           </a:xfrm>
           <a:prstGeom prst="rect">
             <a:avLst/>
@@ -4187,13 +4165,13 @@
               </a:spcAft>
             </a:pPr>
             <a:r>
-              <a:rPr sz="1300" b="1" i="0">
+              <a:rPr sz="1200" b="1" i="0">
                 <a:solidFill>
-                  <a:srgbClr val="02C39A"/>
+                  <a:srgbClr val="8CA3B8"/>
                 </a:solidFill>
                 <a:latin typeface="Calibri"/>
               </a:rPr>
-              <a:t>GitHub Actions   ·   GitHub Container Registry   ·   Docker   ·   PostgreSQL</a:t>
+              <a:t>GitHub Actions  ·  Docker  ·  GHCR  ·  PostgreSQL</a:t>
             </a:r>
           </a:p>
         </p:txBody>
@@ -4233,7 +4211,7 @@
         <p:spPr>
           <a:xfrm>
             <a:off x="640080" y="256032"/>
-            <a:ext cx="5486400" cy="219456"/>
+            <a:ext cx="6858000" cy="219456"/>
           </a:xfrm>
           <a:prstGeom prst="rect">
             <a:avLst/>
@@ -4258,7 +4236,7 @@
                 </a:solidFill>
                 <a:latin typeface="Calibri"/>
               </a:rPr>
-              <a:t>WHAT THE PIPELINE DOES</a:t>
+              <a:t>HOW IT WORKS</a:t>
             </a:r>
           </a:p>
         </p:txBody>
@@ -4291,13 +4269,13 @@
               </a:spcAft>
             </a:pPr>
             <a:r>
-              <a:rPr sz="3200" b="1" i="0">
+              <a:rPr sz="3400" b="1" i="0">
                 <a:solidFill>
                   <a:srgbClr val="065A82"/>
                 </a:solidFill>
                 <a:latin typeface="Cambria"/>
               </a:rPr>
-              <a:t>Every commit is tested; every merge is packaged</a:t>
+              <a:t>Seven automated jobs, no manual steps</a:t>
             </a:r>
           </a:p>
         </p:txBody>
@@ -4310,7 +4288,7 @@
         </p:nvSpPr>
         <p:spPr>
           <a:xfrm>
-            <a:off x="640080" y="1051560"/>
+            <a:off x="640080" y="1060704"/>
             <a:ext cx="10545775" cy="365760"/>
           </a:xfrm>
           <a:prstGeom prst="rect">
@@ -4330,13 +4308,13 @@
               </a:spcAft>
             </a:pPr>
             <a:r>
-              <a:rPr sz="1450" b="0" i="0">
+              <a:rPr sz="1500" b="0" i="0">
                 <a:solidFill>
                   <a:srgbClr val="5C6B7A"/>
                 </a:solidFill>
                 <a:latin typeface="Calibri"/>
               </a:rPr>
-              <a:t>Nothing reaches main untested, and nothing is published unless the tests pass.</a:t>
+              <a:t>Two pipelines: one verifies the code, one ships it.</a:t>
             </a:r>
           </a:p>
         </p:txBody>
@@ -4349,8 +4327,8 @@
         </p:nvSpPr>
         <p:spPr>
           <a:xfrm>
-            <a:off x="640080" y="1691640"/>
-            <a:ext cx="5486400" cy="274320"/>
+            <a:off x="640080" y="1664208"/>
+            <a:ext cx="6400800" cy="274320"/>
           </a:xfrm>
           <a:prstGeom prst="rect">
             <a:avLst/>
@@ -4375,7 +4353,7 @@
                 </a:solidFill>
                 <a:latin typeface="Cambria"/>
               </a:rPr>
-              <a:t>CI  —  on every push and pull request</a:t>
+              <a:t>CI  —  on every push</a:t>
             </a:r>
           </a:p>
         </p:txBody>
@@ -4388,7 +4366,7 @@
         </p:nvSpPr>
         <p:spPr>
           <a:xfrm>
-            <a:off x="640080" y="2103120"/>
+            <a:off x="640080" y="2048256"/>
             <a:ext cx="2478024" cy="1371600"/>
           </a:xfrm>
           <a:prstGeom prst="roundRect">
@@ -4422,13 +4400,63 @@
           <a:bodyPr rtlCol="0" anchor="ctr" wrap="square" lIns="182880" rIns="182880" tIns="137160" bIns="137160"/>
           <a:lstStyle/>
           <a:p>
+            <a:pPr algn="ctr"/>
+          </a:p>
+        </p:txBody>
+      </p:sp>
+      <p:pic>
+        <p:nvPicPr>
+          <p:cNvPr id="7" name="Picture 6" descr="d_quality.png"/>
+          <p:cNvPicPr>
+            <a:picLocks noChangeAspect="1"/>
+          </p:cNvPicPr>
+          <p:nvPr/>
+        </p:nvPicPr>
+        <p:blipFill>
+          <a:blip r:embed="rId2"/>
+          <a:stretch>
+            <a:fillRect/>
+          </a:stretch>
+        </p:blipFill>
+        <p:spPr>
+          <a:xfrm>
+            <a:off x="859536" y="2231136"/>
+            <a:ext cx="566928" cy="566928"/>
+          </a:xfrm>
+          <a:prstGeom prst="rect">
+            <a:avLst/>
+          </a:prstGeom>
+        </p:spPr>
+      </p:pic>
+      <p:sp>
+        <p:nvSpPr>
+          <p:cNvPr id="8" name="TextBox 7"/>
+          <p:cNvSpPr txBox="1"/>
+          <p:nvPr/>
+        </p:nvSpPr>
+        <p:spPr>
+          <a:xfrm>
+            <a:off x="1554480" y="2395728"/>
+            <a:ext cx="1380744" cy="365760"/>
+          </a:xfrm>
+          <a:prstGeom prst="rect">
+            <a:avLst/>
+          </a:prstGeom>
+          <a:noFill/>
+        </p:spPr>
+        <p:txBody>
+          <a:bodyPr wrap="square" lIns="0" rIns="0" tIns="0" bIns="0">
+            <a:spAutoFit/>
+          </a:bodyPr>
+          <a:lstStyle/>
+          <a:p>
             <a:pPr algn="l">
               <a:spcAft>
-                <a:spcPts val="500"/>
+                <a:spcPts val="0"/>
               </a:spcAft>
             </a:pPr>
             <a:r>
-              <a:rPr sz="1450" b="1" i="0">
+              <a:rPr sz="1700" b="1" i="0">
                 <a:solidFill>
                   <a:srgbClr val="065A82"/>
                 </a:solidFill>
@@ -4437,10 +4465,33 @@
               <a:t>Quality</a:t>
             </a:r>
           </a:p>
+        </p:txBody>
+      </p:sp>
+      <p:sp>
+        <p:nvSpPr>
+          <p:cNvPr id="9" name="TextBox 8"/>
+          <p:cNvSpPr txBox="1"/>
+          <p:nvPr/>
+        </p:nvSpPr>
+        <p:spPr>
+          <a:xfrm>
+            <a:off x="859536" y="2944368"/>
+            <a:ext cx="2039112" cy="365760"/>
+          </a:xfrm>
+          <a:prstGeom prst="rect">
+            <a:avLst/>
+          </a:prstGeom>
+          <a:noFill/>
+        </p:spPr>
+        <p:txBody>
+          <a:bodyPr wrap="square" lIns="0" rIns="0" tIns="0" bIns="0">
+            <a:spAutoFit/>
+          </a:bodyPr>
+          <a:lstStyle/>
           <a:p>
             <a:pPr algn="l">
               <a:lnSpc>
-                <a:spcPct val="110000"/>
+                <a:spcPct val="105000"/>
               </a:lnSpc>
               <a:spcAft>
                 <a:spcPts val="0"/>
@@ -4449,31 +4500,31 @@
             <a:r>
               <a:rPr sz="1150" b="0" i="0">
                 <a:solidFill>
-                  <a:srgbClr val="1B2233"/>
+                  <a:srgbClr val="5C6B7A"/>
                 </a:solidFill>
                 <a:latin typeface="Calibri"/>
               </a:rPr>
-              <a:t>No committed .env or node_modules</a:t>
-            </a:r>
-          </a:p>
-        </p:txBody>
-      </p:sp>
-      <p:sp>
-        <p:nvSpPr>
-          <p:cNvPr id="7" name="Oval 6"/>
+              <a:t>no secrets committed</a:t>
+            </a:r>
+          </a:p>
+        </p:txBody>
+      </p:sp>
+      <p:sp>
+        <p:nvSpPr>
+          <p:cNvPr id="10" name="Right Arrow 9"/>
           <p:cNvSpPr/>
           <p:nvPr/>
         </p:nvSpPr>
         <p:spPr>
           <a:xfrm>
-            <a:off x="2615184" y="1883664"/>
-            <a:ext cx="420624" cy="420624"/>
-          </a:xfrm>
-          <a:prstGeom prst="ellipse">
+            <a:off x="3145536" y="2615184"/>
+            <a:ext cx="274320" cy="237744"/>
+          </a:xfrm>
+          <a:prstGeom prst="rightArrow">
             <a:avLst/>
           </a:prstGeom>
           <a:solidFill>
-            <a:srgbClr val="1C7293"/>
+            <a:srgbClr val="B6C7D4"/>
           </a:solidFill>
           <a:ln>
             <a:noFill/>
@@ -4495,38 +4546,31 @@
           </a:fontRef>
         </p:style>
         <p:txBody>
-          <a:bodyPr rtlCol="0" anchor="ctr" lIns="0" rIns="0" tIns="0" bIns="0"/>
+          <a:bodyPr rtlCol="0" anchor="ctr"/>
           <a:lstStyle/>
           <a:p>
             <a:pPr algn="ctr"/>
-            <a:r>
-              <a:rPr sz="1300" b="1">
-                <a:solidFill>
-                  <a:srgbClr val="FFFFFF"/>
-                </a:solidFill>
-                <a:latin typeface="Calibri"/>
-              </a:rPr>
-              <a:t>1</a:t>
-            </a:r>
-          </a:p>
-        </p:txBody>
-      </p:sp>
-      <p:sp>
-        <p:nvSpPr>
-          <p:cNvPr id="8" name="Right Arrow 7"/>
+          </a:p>
+        </p:txBody>
+      </p:sp>
+      <p:sp>
+        <p:nvSpPr>
+          <p:cNvPr id="11" name="Rounded Rectangle 10"/>
           <p:cNvSpPr/>
           <p:nvPr/>
         </p:nvSpPr>
         <p:spPr>
           <a:xfrm>
-            <a:off x="3154680" y="2660904"/>
-            <a:ext cx="292608" cy="256032"/>
-          </a:xfrm>
-          <a:prstGeom prst="rightArrow">
-            <a:avLst/>
+            <a:off x="3447287" y="2048256"/>
+            <a:ext cx="2478024" cy="1371600"/>
+          </a:xfrm>
+          <a:prstGeom prst="roundRect">
+            <a:avLst>
+              <a:gd name="adj" fmla="val 6000"/>
+            </a:avLst>
           </a:prstGeom>
           <a:solidFill>
-            <a:srgbClr val="1C7293"/>
+            <a:srgbClr val="EEF4F8"/>
           </a:solidFill>
           <a:ln>
             <a:noFill/>
@@ -4548,31 +4592,134 @@
           </a:fontRef>
         </p:style>
         <p:txBody>
-          <a:bodyPr rtlCol="0" anchor="ctr"/>
+          <a:bodyPr rtlCol="0" anchor="ctr" wrap="square" lIns="182880" rIns="182880" tIns="137160" bIns="137160"/>
           <a:lstStyle/>
           <a:p>
             <a:pPr algn="ctr"/>
           </a:p>
         </p:txBody>
       </p:sp>
-      <p:sp>
-        <p:nvSpPr>
-          <p:cNvPr id="9" name="Rounded Rectangle 8"/>
+      <p:pic>
+        <p:nvPicPr>
+          <p:cNvPr id="12" name="Picture 11" descr="d_database.png"/>
+          <p:cNvPicPr>
+            <a:picLocks noChangeAspect="1"/>
+          </p:cNvPicPr>
+          <p:nvPr/>
+        </p:nvPicPr>
+        <p:blipFill>
+          <a:blip r:embed="rId3"/>
+          <a:stretch>
+            <a:fillRect/>
+          </a:stretch>
+        </p:blipFill>
+        <p:spPr>
+          <a:xfrm>
+            <a:off x="3666744" y="2231136"/>
+            <a:ext cx="566928" cy="566928"/>
+          </a:xfrm>
+          <a:prstGeom prst="rect">
+            <a:avLst/>
+          </a:prstGeom>
+        </p:spPr>
+      </p:pic>
+      <p:sp>
+        <p:nvSpPr>
+          <p:cNvPr id="13" name="TextBox 12"/>
+          <p:cNvSpPr txBox="1"/>
+          <p:nvPr/>
+        </p:nvSpPr>
+        <p:spPr>
+          <a:xfrm>
+            <a:off x="4361688" y="2395728"/>
+            <a:ext cx="1380744" cy="365760"/>
+          </a:xfrm>
+          <a:prstGeom prst="rect">
+            <a:avLst/>
+          </a:prstGeom>
+          <a:noFill/>
+        </p:spPr>
+        <p:txBody>
+          <a:bodyPr wrap="square" lIns="0" rIns="0" tIns="0" bIns="0">
+            <a:spAutoFit/>
+          </a:bodyPr>
+          <a:lstStyle/>
+          <a:p>
+            <a:pPr algn="l">
+              <a:spcAft>
+                <a:spcPts val="0"/>
+              </a:spcAft>
+            </a:pPr>
+            <a:r>
+              <a:rPr sz="1700" b="1" i="0">
+                <a:solidFill>
+                  <a:srgbClr val="065A82"/>
+                </a:solidFill>
+                <a:latin typeface="Cambria"/>
+              </a:rPr>
+              <a:t>Tests</a:t>
+            </a:r>
+          </a:p>
+        </p:txBody>
+      </p:sp>
+      <p:sp>
+        <p:nvSpPr>
+          <p:cNvPr id="14" name="TextBox 13"/>
+          <p:cNvSpPr txBox="1"/>
+          <p:nvPr/>
+        </p:nvSpPr>
+        <p:spPr>
+          <a:xfrm>
+            <a:off x="3666744" y="2944368"/>
+            <a:ext cx="2039112" cy="365760"/>
+          </a:xfrm>
+          <a:prstGeom prst="rect">
+            <a:avLst/>
+          </a:prstGeom>
+          <a:noFill/>
+        </p:spPr>
+        <p:txBody>
+          <a:bodyPr wrap="square" lIns="0" rIns="0" tIns="0" bIns="0">
+            <a:spAutoFit/>
+          </a:bodyPr>
+          <a:lstStyle/>
+          <a:p>
+            <a:pPr algn="l">
+              <a:lnSpc>
+                <a:spcPct val="105000"/>
+              </a:lnSpc>
+              <a:spcAft>
+                <a:spcPts val="0"/>
+              </a:spcAft>
+            </a:pPr>
+            <a:r>
+              <a:rPr sz="1150" b="0" i="0">
+                <a:solidFill>
+                  <a:srgbClr val="5C6B7A"/>
+                </a:solidFill>
+                <a:latin typeface="Calibri"/>
+              </a:rPr>
+              <a:t>real PostgreSQL, 17 tests</a:t>
+            </a:r>
+          </a:p>
+        </p:txBody>
+      </p:sp>
+      <p:sp>
+        <p:nvSpPr>
+          <p:cNvPr id="15" name="Right Arrow 14"/>
           <p:cNvSpPr/>
           <p:nvPr/>
         </p:nvSpPr>
         <p:spPr>
           <a:xfrm>
-            <a:off x="3447287" y="2103120"/>
-            <a:ext cx="2478024" cy="1371600"/>
-          </a:xfrm>
-          <a:prstGeom prst="roundRect">
-            <a:avLst>
-              <a:gd name="adj" fmla="val 6000"/>
-            </a:avLst>
+            <a:off x="5952744" y="2615184"/>
+            <a:ext cx="274320" cy="237744"/>
+          </a:xfrm>
+          <a:prstGeom prst="rightArrow">
+            <a:avLst/>
           </a:prstGeom>
           <a:solidFill>
-            <a:srgbClr val="EEF4F8"/>
+            <a:srgbClr val="B6C7D4"/>
           </a:solidFill>
           <a:ln>
             <a:noFill/>
@@ -4594,61 +4741,31 @@
           </a:fontRef>
         </p:style>
         <p:txBody>
-          <a:bodyPr rtlCol="0" anchor="ctr" wrap="square" lIns="182880" rIns="182880" tIns="137160" bIns="137160"/>
-          <a:lstStyle/>
-          <a:p>
-            <a:pPr algn="l">
-              <a:spcAft>
-                <a:spcPts val="500"/>
-              </a:spcAft>
-            </a:pPr>
-            <a:r>
-              <a:rPr sz="1450" b="1" i="0">
-                <a:solidFill>
-                  <a:srgbClr val="065A82"/>
-                </a:solidFill>
-                <a:latin typeface="Cambria"/>
-              </a:rPr>
-              <a:t>Backend tests</a:t>
-            </a:r>
-          </a:p>
-          <a:p>
-            <a:pPr algn="l">
-              <a:lnSpc>
-                <a:spcPct val="110000"/>
-              </a:lnSpc>
-              <a:spcAft>
-                <a:spcPts val="0"/>
-              </a:spcAft>
-            </a:pPr>
-            <a:r>
-              <a:rPr sz="1150" b="0" i="0">
-                <a:solidFill>
-                  <a:srgbClr val="1B2233"/>
-                </a:solidFill>
-                <a:latin typeface="Calibri"/>
-              </a:rPr>
-              <a:t>Real PostgreSQL container, 17 tests, health check</a:t>
-            </a:r>
-          </a:p>
-        </p:txBody>
-      </p:sp>
-      <p:sp>
-        <p:nvSpPr>
-          <p:cNvPr id="10" name="Oval 9"/>
+          <a:bodyPr rtlCol="0" anchor="ctr"/>
+          <a:lstStyle/>
+          <a:p>
+            <a:pPr algn="ctr"/>
+          </a:p>
+        </p:txBody>
+      </p:sp>
+      <p:sp>
+        <p:nvSpPr>
+          <p:cNvPr id="16" name="Rounded Rectangle 15"/>
           <p:cNvSpPr/>
           <p:nvPr/>
         </p:nvSpPr>
         <p:spPr>
           <a:xfrm>
-            <a:off x="5422392" y="1883664"/>
-            <a:ext cx="420624" cy="420624"/>
-          </a:xfrm>
-          <a:prstGeom prst="ellipse">
-            <a:avLst/>
+            <a:off x="6254496" y="2048256"/>
+            <a:ext cx="2478024" cy="1371600"/>
+          </a:xfrm>
+          <a:prstGeom prst="roundRect">
+            <a:avLst>
+              <a:gd name="adj" fmla="val 6000"/>
+            </a:avLst>
           </a:prstGeom>
           <a:solidFill>
-            <a:srgbClr val="1C7293"/>
+            <a:srgbClr val="EEF4F8"/>
           </a:solidFill>
           <a:ln>
             <a:noFill/>
@@ -4670,38 +4787,134 @@
           </a:fontRef>
         </p:style>
         <p:txBody>
-          <a:bodyPr rtlCol="0" anchor="ctr" lIns="0" rIns="0" tIns="0" bIns="0"/>
+          <a:bodyPr rtlCol="0" anchor="ctr" wrap="square" lIns="182880" rIns="182880" tIns="137160" bIns="137160"/>
           <a:lstStyle/>
           <a:p>
             <a:pPr algn="ctr"/>
-            <a:r>
-              <a:rPr sz="1300" b="1">
+          </a:p>
+        </p:txBody>
+      </p:sp>
+      <p:pic>
+        <p:nvPicPr>
+          <p:cNvPr id="17" name="Picture 16" descr="d_build.png"/>
+          <p:cNvPicPr>
+            <a:picLocks noChangeAspect="1"/>
+          </p:cNvPicPr>
+          <p:nvPr/>
+        </p:nvPicPr>
+        <p:blipFill>
+          <a:blip r:embed="rId4"/>
+          <a:stretch>
+            <a:fillRect/>
+          </a:stretch>
+        </p:blipFill>
+        <p:spPr>
+          <a:xfrm>
+            <a:off x="6473952" y="2231136"/>
+            <a:ext cx="566928" cy="566928"/>
+          </a:xfrm>
+          <a:prstGeom prst="rect">
+            <a:avLst/>
+          </a:prstGeom>
+        </p:spPr>
+      </p:pic>
+      <p:sp>
+        <p:nvSpPr>
+          <p:cNvPr id="18" name="TextBox 17"/>
+          <p:cNvSpPr txBox="1"/>
+          <p:nvPr/>
+        </p:nvSpPr>
+        <p:spPr>
+          <a:xfrm>
+            <a:off x="7168896" y="2395728"/>
+            <a:ext cx="1380744" cy="365760"/>
+          </a:xfrm>
+          <a:prstGeom prst="rect">
+            <a:avLst/>
+          </a:prstGeom>
+          <a:noFill/>
+        </p:spPr>
+        <p:txBody>
+          <a:bodyPr wrap="square" lIns="0" rIns="0" tIns="0" bIns="0">
+            <a:spAutoFit/>
+          </a:bodyPr>
+          <a:lstStyle/>
+          <a:p>
+            <a:pPr algn="l">
+              <a:spcAft>
+                <a:spcPts val="0"/>
+              </a:spcAft>
+            </a:pPr>
+            <a:r>
+              <a:rPr sz="1700" b="1" i="0">
                 <a:solidFill>
-                  <a:srgbClr val="FFFFFF"/>
+                  <a:srgbClr val="065A82"/>
+                </a:solidFill>
+                <a:latin typeface="Cambria"/>
+              </a:rPr>
+              <a:t>Build</a:t>
+            </a:r>
+          </a:p>
+        </p:txBody>
+      </p:sp>
+      <p:sp>
+        <p:nvSpPr>
+          <p:cNvPr id="19" name="TextBox 18"/>
+          <p:cNvSpPr txBox="1"/>
+          <p:nvPr/>
+        </p:nvSpPr>
+        <p:spPr>
+          <a:xfrm>
+            <a:off x="6473952" y="2944368"/>
+            <a:ext cx="2039112" cy="365760"/>
+          </a:xfrm>
+          <a:prstGeom prst="rect">
+            <a:avLst/>
+          </a:prstGeom>
+          <a:noFill/>
+        </p:spPr>
+        <p:txBody>
+          <a:bodyPr wrap="square" lIns="0" rIns="0" tIns="0" bIns="0">
+            <a:spAutoFit/>
+          </a:bodyPr>
+          <a:lstStyle/>
+          <a:p>
+            <a:pPr algn="l">
+              <a:lnSpc>
+                <a:spcPct val="105000"/>
+              </a:lnSpc>
+              <a:spcAft>
+                <a:spcPts val="0"/>
+              </a:spcAft>
+            </a:pPr>
+            <a:r>
+              <a:rPr sz="1150" b="0" i="0">
+                <a:solidFill>
+                  <a:srgbClr val="5C6B7A"/>
                 </a:solidFill>
                 <a:latin typeface="Calibri"/>
               </a:rPr>
-              <a:t>2</a:t>
-            </a:r>
-          </a:p>
-        </p:txBody>
-      </p:sp>
-      <p:sp>
-        <p:nvSpPr>
-          <p:cNvPr id="11" name="Right Arrow 10"/>
+              <a:t>production build</a:t>
+            </a:r>
+          </a:p>
+        </p:txBody>
+      </p:sp>
+      <p:sp>
+        <p:nvSpPr>
+          <p:cNvPr id="20" name="Right Arrow 19"/>
           <p:cNvSpPr/>
           <p:nvPr/>
         </p:nvSpPr>
         <p:spPr>
           <a:xfrm>
-            <a:off x="5961888" y="2660904"/>
-            <a:ext cx="292608" cy="256032"/>
+            <a:off x="8759952" y="2615184"/>
+            <a:ext cx="274320" cy="237744"/>
           </a:xfrm>
           <a:prstGeom prst="rightArrow">
             <a:avLst/>
           </a:prstGeom>
           <a:solidFill>
-            <a:srgbClr val="1C7293"/>
+            <a:srgbClr val="B6C7D4"/>
           </a:solidFill>
           <a:ln>
             <a:noFill/>
@@ -4732,13 +4945,13 @@
       </p:sp>
       <p:sp>
         <p:nvSpPr>
-          <p:cNvPr id="12" name="Rounded Rectangle 11"/>
+          <p:cNvPr id="21" name="Rounded Rectangle 20"/>
           <p:cNvSpPr/>
           <p:nvPr/>
         </p:nvSpPr>
         <p:spPr>
           <a:xfrm>
-            <a:off x="6254496" y="2103120"/>
+            <a:off x="9061704" y="2048256"/>
             <a:ext cx="2478024" cy="1371600"/>
           </a:xfrm>
           <a:prstGeom prst="roundRect">
@@ -4772,25 +4985,98 @@
           <a:bodyPr rtlCol="0" anchor="ctr" wrap="square" lIns="182880" rIns="182880" tIns="137160" bIns="137160"/>
           <a:lstStyle/>
           <a:p>
+            <a:pPr algn="ctr"/>
+          </a:p>
+        </p:txBody>
+      </p:sp>
+      <p:pic>
+        <p:nvPicPr>
+          <p:cNvPr id="22" name="Picture 21" descr="d_container.png"/>
+          <p:cNvPicPr>
+            <a:picLocks noChangeAspect="1"/>
+          </p:cNvPicPr>
+          <p:nvPr/>
+        </p:nvPicPr>
+        <p:blipFill>
+          <a:blip r:embed="rId5"/>
+          <a:stretch>
+            <a:fillRect/>
+          </a:stretch>
+        </p:blipFill>
+        <p:spPr>
+          <a:xfrm>
+            <a:off x="9281160" y="2231136"/>
+            <a:ext cx="566928" cy="566928"/>
+          </a:xfrm>
+          <a:prstGeom prst="rect">
+            <a:avLst/>
+          </a:prstGeom>
+        </p:spPr>
+      </p:pic>
+      <p:sp>
+        <p:nvSpPr>
+          <p:cNvPr id="23" name="TextBox 22"/>
+          <p:cNvSpPr txBox="1"/>
+          <p:nvPr/>
+        </p:nvSpPr>
+        <p:spPr>
+          <a:xfrm>
+            <a:off x="9976104" y="2395728"/>
+            <a:ext cx="1380744" cy="365760"/>
+          </a:xfrm>
+          <a:prstGeom prst="rect">
+            <a:avLst/>
+          </a:prstGeom>
+          <a:noFill/>
+        </p:spPr>
+        <p:txBody>
+          <a:bodyPr wrap="square" lIns="0" rIns="0" tIns="0" bIns="0">
+            <a:spAutoFit/>
+          </a:bodyPr>
+          <a:lstStyle/>
+          <a:p>
             <a:pPr algn="l">
               <a:spcAft>
-                <a:spcPts val="500"/>
+                <a:spcPts val="0"/>
               </a:spcAft>
             </a:pPr>
             <a:r>
-              <a:rPr sz="1450" b="1" i="0">
+              <a:rPr sz="1700" b="1" i="0">
                 <a:solidFill>
                   <a:srgbClr val="065A82"/>
                 </a:solidFill>
                 <a:latin typeface="Cambria"/>
               </a:rPr>
-              <a:t>Frontend build</a:t>
-            </a:r>
-          </a:p>
+              <a:t>Image</a:t>
+            </a:r>
+          </a:p>
+        </p:txBody>
+      </p:sp>
+      <p:sp>
+        <p:nvSpPr>
+          <p:cNvPr id="24" name="TextBox 23"/>
+          <p:cNvSpPr txBox="1"/>
+          <p:nvPr/>
+        </p:nvSpPr>
+        <p:spPr>
+          <a:xfrm>
+            <a:off x="9281160" y="2944368"/>
+            <a:ext cx="2039112" cy="365760"/>
+          </a:xfrm>
+          <a:prstGeom prst="rect">
+            <a:avLst/>
+          </a:prstGeom>
+          <a:noFill/>
+        </p:spPr>
+        <p:txBody>
+          <a:bodyPr wrap="square" lIns="0" rIns="0" tIns="0" bIns="0">
+            <a:spAutoFit/>
+          </a:bodyPr>
+          <a:lstStyle/>
           <a:p>
             <a:pPr algn="l">
               <a:lnSpc>
-                <a:spcPct val="110000"/>
+                <a:spcPct val="105000"/>
               </a:lnSpc>
               <a:spcAft>
                 <a:spcPts val="0"/>
@@ -4799,31 +5085,72 @@
             <a:r>
               <a:rPr sz="1150" b="0" i="0">
                 <a:solidFill>
-                  <a:srgbClr val="1B2233"/>
+                  <a:srgbClr val="5C6B7A"/>
                 </a:solidFill>
                 <a:latin typeface="Calibri"/>
               </a:rPr>
-              <a:t>Production next build must compile</a:t>
-            </a:r>
-          </a:p>
-        </p:txBody>
-      </p:sp>
-      <p:sp>
-        <p:nvSpPr>
-          <p:cNvPr id="13" name="Oval 12"/>
+              <a:t>both containers</a:t>
+            </a:r>
+          </a:p>
+        </p:txBody>
+      </p:sp>
+      <p:sp>
+        <p:nvSpPr>
+          <p:cNvPr id="25" name="TextBox 24"/>
+          <p:cNvSpPr txBox="1"/>
+          <p:nvPr/>
+        </p:nvSpPr>
+        <p:spPr>
+          <a:xfrm>
+            <a:off x="640080" y="3913632"/>
+            <a:ext cx="7315200" cy="274320"/>
+          </a:xfrm>
+          <a:prstGeom prst="rect">
+            <a:avLst/>
+          </a:prstGeom>
+          <a:noFill/>
+        </p:spPr>
+        <p:txBody>
+          <a:bodyPr wrap="square" lIns="0" rIns="0" tIns="0" bIns="0">
+            <a:spAutoFit/>
+          </a:bodyPr>
+          <a:lstStyle/>
+          <a:p>
+            <a:pPr algn="l">
+              <a:spcAft>
+                <a:spcPts val="0"/>
+              </a:spcAft>
+            </a:pPr>
+            <a:r>
+              <a:rPr sz="1500" b="1" i="0">
+                <a:solidFill>
+                  <a:srgbClr val="065A82"/>
+                </a:solidFill>
+                <a:latin typeface="Cambria"/>
+              </a:rPr>
+              <a:t>CD  —  on every merge into main</a:t>
+            </a:r>
+          </a:p>
+        </p:txBody>
+      </p:sp>
+      <p:sp>
+        <p:nvSpPr>
+          <p:cNvPr id="26" name="Rounded Rectangle 25"/>
           <p:cNvSpPr/>
           <p:nvPr/>
         </p:nvSpPr>
         <p:spPr>
           <a:xfrm>
-            <a:off x="8229600" y="1883664"/>
-            <a:ext cx="420624" cy="420624"/>
-          </a:xfrm>
-          <a:prstGeom prst="ellipse">
-            <a:avLst/>
+            <a:off x="640080" y="4297680"/>
+            <a:ext cx="3364992" cy="1371600"/>
+          </a:xfrm>
+          <a:prstGeom prst="roundRect">
+            <a:avLst>
+              <a:gd name="adj" fmla="val 6000"/>
+            </a:avLst>
           </a:prstGeom>
           <a:solidFill>
-            <a:srgbClr val="1C7293"/>
+            <a:srgbClr val="21295C"/>
           </a:solidFill>
           <a:ln>
             <a:noFill/>
@@ -4845,38 +5172,134 @@
           </a:fontRef>
         </p:style>
         <p:txBody>
-          <a:bodyPr rtlCol="0" anchor="ctr" lIns="0" rIns="0" tIns="0" bIns="0"/>
+          <a:bodyPr rtlCol="0" anchor="ctr" wrap="square" lIns="182880" rIns="182880" tIns="137160" bIns="137160"/>
           <a:lstStyle/>
           <a:p>
             <a:pPr algn="ctr"/>
-            <a:r>
-              <a:rPr sz="1300" b="1">
+          </a:p>
+        </p:txBody>
+      </p:sp>
+      <p:pic>
+        <p:nvPicPr>
+          <p:cNvPr id="27" name="Picture 26" descr="i_gate.png"/>
+          <p:cNvPicPr>
+            <a:picLocks noChangeAspect="1"/>
+          </p:cNvPicPr>
+          <p:nvPr/>
+        </p:nvPicPr>
+        <p:blipFill>
+          <a:blip r:embed="rId6"/>
+          <a:stretch>
+            <a:fillRect/>
+          </a:stretch>
+        </p:blipFill>
+        <p:spPr>
+          <a:xfrm>
+            <a:off x="877824" y="4480560"/>
+            <a:ext cx="566928" cy="566928"/>
+          </a:xfrm>
+          <a:prstGeom prst="rect">
+            <a:avLst/>
+          </a:prstGeom>
+        </p:spPr>
+      </p:pic>
+      <p:sp>
+        <p:nvSpPr>
+          <p:cNvPr id="28" name="TextBox 27"/>
+          <p:cNvSpPr txBox="1"/>
+          <p:nvPr/>
+        </p:nvSpPr>
+        <p:spPr>
+          <a:xfrm>
+            <a:off x="1600200" y="4645152"/>
+            <a:ext cx="2221992" cy="365760"/>
+          </a:xfrm>
+          <a:prstGeom prst="rect">
+            <a:avLst/>
+          </a:prstGeom>
+          <a:noFill/>
+        </p:spPr>
+        <p:txBody>
+          <a:bodyPr wrap="square" lIns="0" rIns="0" tIns="0" bIns="0">
+            <a:spAutoFit/>
+          </a:bodyPr>
+          <a:lstStyle/>
+          <a:p>
+            <a:pPr algn="l">
+              <a:spcAft>
+                <a:spcPts val="0"/>
+              </a:spcAft>
+            </a:pPr>
+            <a:r>
+              <a:rPr sz="1700" b="1" i="0">
                 <a:solidFill>
                   <a:srgbClr val="FFFFFF"/>
                 </a:solidFill>
+                <a:latin typeface="Cambria"/>
+              </a:rPr>
+              <a:t>Gate</a:t>
+            </a:r>
+          </a:p>
+        </p:txBody>
+      </p:sp>
+      <p:sp>
+        <p:nvSpPr>
+          <p:cNvPr id="29" name="TextBox 28"/>
+          <p:cNvSpPr txBox="1"/>
+          <p:nvPr/>
+        </p:nvSpPr>
+        <p:spPr>
+          <a:xfrm>
+            <a:off x="877824" y="5193792"/>
+            <a:ext cx="2889504" cy="365760"/>
+          </a:xfrm>
+          <a:prstGeom prst="rect">
+            <a:avLst/>
+          </a:prstGeom>
+          <a:noFill/>
+        </p:spPr>
+        <p:txBody>
+          <a:bodyPr wrap="square" lIns="0" rIns="0" tIns="0" bIns="0">
+            <a:spAutoFit/>
+          </a:bodyPr>
+          <a:lstStyle/>
+          <a:p>
+            <a:pPr algn="l">
+              <a:lnSpc>
+                <a:spcPct val="105000"/>
+              </a:lnSpc>
+              <a:spcAft>
+                <a:spcPts val="0"/>
+              </a:spcAft>
+            </a:pPr>
+            <a:r>
+              <a:rPr sz="1150" b="0" i="0">
+                <a:solidFill>
+                  <a:srgbClr val="C5D5E0"/>
+                </a:solidFill>
                 <a:latin typeface="Calibri"/>
               </a:rPr>
-              <a:t>3</a:t>
-            </a:r>
-          </a:p>
-        </p:txBody>
-      </p:sp>
-      <p:sp>
-        <p:nvSpPr>
-          <p:cNvPr id="14" name="Right Arrow 13"/>
+              <a:t>CI must pass first</a:t>
+            </a:r>
+          </a:p>
+        </p:txBody>
+      </p:sp>
+      <p:sp>
+        <p:nvSpPr>
+          <p:cNvPr id="30" name="Right Arrow 29"/>
           <p:cNvSpPr/>
           <p:nvPr/>
         </p:nvSpPr>
         <p:spPr>
           <a:xfrm>
-            <a:off x="8769096" y="2660904"/>
-            <a:ext cx="292608" cy="256032"/>
+            <a:off x="4059935" y="4864608"/>
+            <a:ext cx="274320" cy="237744"/>
           </a:xfrm>
           <a:prstGeom prst="rightArrow">
             <a:avLst/>
           </a:prstGeom>
           <a:solidFill>
-            <a:srgbClr val="1C7293"/>
+            <a:srgbClr val="02C39A"/>
           </a:solidFill>
           <a:ln>
             <a:noFill/>
@@ -4907,14 +5330,14 @@
       </p:sp>
       <p:sp>
         <p:nvSpPr>
-          <p:cNvPr id="15" name="Rounded Rectangle 14"/>
+          <p:cNvPr id="31" name="Rounded Rectangle 30"/>
           <p:cNvSpPr/>
           <p:nvPr/>
         </p:nvSpPr>
         <p:spPr>
           <a:xfrm>
-            <a:off x="9061704" y="2103120"/>
-            <a:ext cx="2478024" cy="1371600"/>
+            <a:off x="4407408" y="4297680"/>
+            <a:ext cx="3364992" cy="1371600"/>
           </a:xfrm>
           <a:prstGeom prst="roundRect">
             <a:avLst>
@@ -4922,7 +5345,7 @@
             </a:avLst>
           </a:prstGeom>
           <a:solidFill>
-            <a:srgbClr val="EEF4F8"/>
+            <a:srgbClr val="21295C"/>
           </a:solidFill>
           <a:ln>
             <a:noFill/>
@@ -4947,25 +5370,98 @@
           <a:bodyPr rtlCol="0" anchor="ctr" wrap="square" lIns="182880" rIns="182880" tIns="137160" bIns="137160"/>
           <a:lstStyle/>
           <a:p>
+            <a:pPr algn="ctr"/>
+          </a:p>
+        </p:txBody>
+      </p:sp>
+      <p:pic>
+        <p:nvPicPr>
+          <p:cNvPr id="32" name="Picture 31" descr="i_publish.png"/>
+          <p:cNvPicPr>
+            <a:picLocks noChangeAspect="1"/>
+          </p:cNvPicPr>
+          <p:nvPr/>
+        </p:nvPicPr>
+        <p:blipFill>
+          <a:blip r:embed="rId7"/>
+          <a:stretch>
+            <a:fillRect/>
+          </a:stretch>
+        </p:blipFill>
+        <p:spPr>
+          <a:xfrm>
+            <a:off x="4645152" y="4480560"/>
+            <a:ext cx="566928" cy="566928"/>
+          </a:xfrm>
+          <a:prstGeom prst="rect">
+            <a:avLst/>
+          </a:prstGeom>
+        </p:spPr>
+      </p:pic>
+      <p:sp>
+        <p:nvSpPr>
+          <p:cNvPr id="33" name="TextBox 32"/>
+          <p:cNvSpPr txBox="1"/>
+          <p:nvPr/>
+        </p:nvSpPr>
+        <p:spPr>
+          <a:xfrm>
+            <a:off x="5367528" y="4645152"/>
+            <a:ext cx="2221992" cy="365760"/>
+          </a:xfrm>
+          <a:prstGeom prst="rect">
+            <a:avLst/>
+          </a:prstGeom>
+          <a:noFill/>
+        </p:spPr>
+        <p:txBody>
+          <a:bodyPr wrap="square" lIns="0" rIns="0" tIns="0" bIns="0">
+            <a:spAutoFit/>
+          </a:bodyPr>
+          <a:lstStyle/>
+          <a:p>
             <a:pPr algn="l">
               <a:spcAft>
-                <a:spcPts val="500"/>
+                <a:spcPts val="0"/>
               </a:spcAft>
             </a:pPr>
             <a:r>
-              <a:rPr sz="1450" b="1" i="0">
+              <a:rPr sz="1700" b="1" i="0">
                 <a:solidFill>
-                  <a:srgbClr val="065A82"/>
+                  <a:srgbClr val="FFFFFF"/>
                 </a:solidFill>
                 <a:latin typeface="Cambria"/>
               </a:rPr>
-              <a:t>Docker build</a:t>
-            </a:r>
-          </a:p>
+              <a:t>Publish</a:t>
+            </a:r>
+          </a:p>
+        </p:txBody>
+      </p:sp>
+      <p:sp>
+        <p:nvSpPr>
+          <p:cNvPr id="34" name="TextBox 33"/>
+          <p:cNvSpPr txBox="1"/>
+          <p:nvPr/>
+        </p:nvSpPr>
+        <p:spPr>
+          <a:xfrm>
+            <a:off x="4645152" y="5193792"/>
+            <a:ext cx="2889504" cy="365760"/>
+          </a:xfrm>
+          <a:prstGeom prst="rect">
+            <a:avLst/>
+          </a:prstGeom>
+          <a:noFill/>
+        </p:spPr>
+        <p:txBody>
+          <a:bodyPr wrap="square" lIns="0" rIns="0" tIns="0" bIns="0">
+            <a:spAutoFit/>
+          </a:bodyPr>
+          <a:lstStyle/>
           <a:p>
             <a:pPr algn="l">
               <a:lnSpc>
-                <a:spcPct val="110000"/>
+                <a:spcPct val="105000"/>
               </a:lnSpc>
               <a:spcAft>
                 <a:spcPts val="0"/>
@@ -4974,31 +5470,31 @@
             <a:r>
               <a:rPr sz="1150" b="0" i="0">
                 <a:solidFill>
-                  <a:srgbClr val="1B2233"/>
+                  <a:srgbClr val="C5D5E0"/>
                 </a:solidFill>
                 <a:latin typeface="Calibri"/>
               </a:rPr>
-              <a:t>Both images must build</a:t>
-            </a:r>
-          </a:p>
-        </p:txBody>
-      </p:sp>
-      <p:sp>
-        <p:nvSpPr>
-          <p:cNvPr id="16" name="Oval 15"/>
+              <a:t>images to GHCR, tagged</a:t>
+            </a:r>
+          </a:p>
+        </p:txBody>
+      </p:sp>
+      <p:sp>
+        <p:nvSpPr>
+          <p:cNvPr id="35" name="Right Arrow 34"/>
           <p:cNvSpPr/>
           <p:nvPr/>
         </p:nvSpPr>
         <p:spPr>
           <a:xfrm>
-            <a:off x="11036808" y="1883664"/>
-            <a:ext cx="420624" cy="420624"/>
-          </a:xfrm>
-          <a:prstGeom prst="ellipse">
+            <a:off x="7827264" y="4864608"/>
+            <a:ext cx="274320" cy="237744"/>
+          </a:xfrm>
+          <a:prstGeom prst="rightArrow">
             <a:avLst/>
           </a:prstGeom>
           <a:solidFill>
-            <a:srgbClr val="1C7293"/>
+            <a:srgbClr val="02C39A"/>
           </a:solidFill>
           <a:ln>
             <a:noFill/>
@@ -5020,109 +5516,22 @@
           </a:fontRef>
         </p:style>
         <p:txBody>
-          <a:bodyPr rtlCol="0" anchor="ctr" lIns="0" rIns="0" tIns="0" bIns="0"/>
+          <a:bodyPr rtlCol="0" anchor="ctr"/>
           <a:lstStyle/>
           <a:p>
             <a:pPr algn="ctr"/>
-            <a:r>
-              <a:rPr sz="1300" b="1">
-                <a:solidFill>
-                  <a:srgbClr val="FFFFFF"/>
-                </a:solidFill>
-                <a:latin typeface="Calibri"/>
-              </a:rPr>
-              <a:t>4</a:t>
-            </a:r>
-          </a:p>
-        </p:txBody>
-      </p:sp>
-      <p:sp>
-        <p:nvSpPr>
-          <p:cNvPr id="17" name="TextBox 16"/>
-          <p:cNvSpPr txBox="1"/>
-          <p:nvPr/>
-        </p:nvSpPr>
-        <p:spPr>
-          <a:xfrm>
-            <a:off x="640080" y="3584448"/>
-            <a:ext cx="10881360" cy="274320"/>
-          </a:xfrm>
-          <a:prstGeom prst="rect">
-            <a:avLst/>
-          </a:prstGeom>
-          <a:noFill/>
-        </p:spPr>
-        <p:txBody>
-          <a:bodyPr wrap="square" lIns="0" rIns="0" tIns="0" bIns="0">
-            <a:spAutoFit/>
-          </a:bodyPr>
-          <a:lstStyle/>
-          <a:p>
-            <a:pPr algn="l">
-              <a:spcAft>
-                <a:spcPts val="0"/>
-              </a:spcAft>
-            </a:pPr>
-            <a:r>
-              <a:rPr sz="1250" b="0" i="1">
-                <a:solidFill>
-                  <a:srgbClr val="5C6B7A"/>
-                </a:solidFill>
-                <a:latin typeface="Calibri"/>
-              </a:rPr>
-              <a:t>Stages 2 and 3 run in parallel; stage 4 waits for both. A bad commit turns the pull request red before it can be merged.</a:t>
-            </a:r>
-          </a:p>
-        </p:txBody>
-      </p:sp>
-      <p:sp>
-        <p:nvSpPr>
-          <p:cNvPr id="18" name="TextBox 17"/>
-          <p:cNvSpPr txBox="1"/>
-          <p:nvPr/>
-        </p:nvSpPr>
-        <p:spPr>
-          <a:xfrm>
-            <a:off x="640080" y="4114800"/>
-            <a:ext cx="7315200" cy="274320"/>
-          </a:xfrm>
-          <a:prstGeom prst="rect">
-            <a:avLst/>
-          </a:prstGeom>
-          <a:noFill/>
-        </p:spPr>
-        <p:txBody>
-          <a:bodyPr wrap="square" lIns="0" rIns="0" tIns="0" bIns="0">
-            <a:spAutoFit/>
-          </a:bodyPr>
-          <a:lstStyle/>
-          <a:p>
-            <a:pPr algn="l">
-              <a:spcAft>
-                <a:spcPts val="0"/>
-              </a:spcAft>
-            </a:pPr>
-            <a:r>
-              <a:rPr sz="1500" b="1" i="0">
-                <a:solidFill>
-                  <a:srgbClr val="065A82"/>
-                </a:solidFill>
-                <a:latin typeface="Cambria"/>
-              </a:rPr>
-              <a:t>CD  —  when a pull request is merged into main</a:t>
-            </a:r>
-          </a:p>
-        </p:txBody>
-      </p:sp>
-      <p:sp>
-        <p:nvSpPr>
-          <p:cNvPr id="19" name="Rounded Rectangle 18"/>
+          </a:p>
+        </p:txBody>
+      </p:sp>
+      <p:sp>
+        <p:nvSpPr>
+          <p:cNvPr id="36" name="Rounded Rectangle 35"/>
           <p:cNvSpPr/>
           <p:nvPr/>
         </p:nvSpPr>
         <p:spPr>
           <a:xfrm>
-            <a:off x="640080" y="4526280"/>
+            <a:off x="8174736" y="4297680"/>
             <a:ext cx="3364992" cy="1371600"/>
           </a:xfrm>
           <a:prstGeom prst="roundRect">
@@ -5156,25 +5565,98 @@
           <a:bodyPr rtlCol="0" anchor="ctr" wrap="square" lIns="182880" rIns="182880" tIns="137160" bIns="137160"/>
           <a:lstStyle/>
           <a:p>
+            <a:pPr algn="ctr"/>
+          </a:p>
+        </p:txBody>
+      </p:sp>
+      <p:pic>
+        <p:nvPicPr>
+          <p:cNvPr id="37" name="Picture 36" descr="i_deploy.png"/>
+          <p:cNvPicPr>
+            <a:picLocks noChangeAspect="1"/>
+          </p:cNvPicPr>
+          <p:nvPr/>
+        </p:nvPicPr>
+        <p:blipFill>
+          <a:blip r:embed="rId8"/>
+          <a:stretch>
+            <a:fillRect/>
+          </a:stretch>
+        </p:blipFill>
+        <p:spPr>
+          <a:xfrm>
+            <a:off x="8412480" y="4480560"/>
+            <a:ext cx="566928" cy="566928"/>
+          </a:xfrm>
+          <a:prstGeom prst="rect">
+            <a:avLst/>
+          </a:prstGeom>
+        </p:spPr>
+      </p:pic>
+      <p:sp>
+        <p:nvSpPr>
+          <p:cNvPr id="38" name="TextBox 37"/>
+          <p:cNvSpPr txBox="1"/>
+          <p:nvPr/>
+        </p:nvSpPr>
+        <p:spPr>
+          <a:xfrm>
+            <a:off x="9134856" y="4645152"/>
+            <a:ext cx="2221992" cy="365760"/>
+          </a:xfrm>
+          <a:prstGeom prst="rect">
+            <a:avLst/>
+          </a:prstGeom>
+          <a:noFill/>
+        </p:spPr>
+        <p:txBody>
+          <a:bodyPr wrap="square" lIns="0" rIns="0" tIns="0" bIns="0">
+            <a:spAutoFit/>
+          </a:bodyPr>
+          <a:lstStyle/>
+          <a:p>
             <a:pPr algn="l">
               <a:spcAft>
-                <a:spcPts val="500"/>
+                <a:spcPts val="0"/>
               </a:spcAft>
             </a:pPr>
             <a:r>
-              <a:rPr sz="1450" b="1" i="0">
+              <a:rPr sz="1700" b="1" i="0">
                 <a:solidFill>
                   <a:srgbClr val="FFFFFF"/>
                 </a:solidFill>
                 <a:latin typeface="Cambria"/>
               </a:rPr>
-              <a:t>CI gate</a:t>
-            </a:r>
-          </a:p>
+              <a:t>Release</a:t>
+            </a:r>
+          </a:p>
+        </p:txBody>
+      </p:sp>
+      <p:sp>
+        <p:nvSpPr>
+          <p:cNvPr id="39" name="TextBox 38"/>
+          <p:cNvSpPr txBox="1"/>
+          <p:nvPr/>
+        </p:nvSpPr>
+        <p:spPr>
+          <a:xfrm>
+            <a:off x="8412480" y="5193792"/>
+            <a:ext cx="2889504" cy="365760"/>
+          </a:xfrm>
+          <a:prstGeom prst="rect">
+            <a:avLst/>
+          </a:prstGeom>
+          <a:noFill/>
+        </p:spPr>
+        <p:txBody>
+          <a:bodyPr wrap="square" lIns="0" rIns="0" tIns="0" bIns="0">
+            <a:spAutoFit/>
+          </a:bodyPr>
+          <a:lstStyle/>
           <a:p>
             <a:pPr algn="l">
               <a:lnSpc>
-                <a:spcPct val="110000"/>
+                <a:spcPct val="105000"/>
               </a:lnSpc>
               <a:spcAft>
                 <a:spcPts val="0"/>
@@ -5187,423 +5669,20 @@
                 </a:solidFill>
                 <a:latin typeface="Calibri"/>
               </a:rPr>
-              <a:t>Re-runs the whole CI pipeline first</a:t>
-            </a:r>
-          </a:p>
-        </p:txBody>
-      </p:sp>
-      <p:sp>
-        <p:nvSpPr>
-          <p:cNvPr id="20" name="Oval 19"/>
-          <p:cNvSpPr/>
-          <p:nvPr/>
-        </p:nvSpPr>
-        <p:spPr>
-          <a:xfrm>
-            <a:off x="3502152" y="4306824"/>
-            <a:ext cx="420624" cy="420624"/>
-          </a:xfrm>
-          <a:prstGeom prst="ellipse">
-            <a:avLst/>
-          </a:prstGeom>
-          <a:solidFill>
-            <a:srgbClr val="02C39A"/>
-          </a:solidFill>
-          <a:ln>
-            <a:noFill/>
-          </a:ln>
-          <a:effectLst/>
-        </p:spPr>
-        <p:style>
-          <a:lnRef idx="1">
-            <a:schemeClr val="accent1"/>
-          </a:lnRef>
-          <a:fillRef idx="3">
-            <a:schemeClr val="accent1"/>
-          </a:fillRef>
-          <a:effectRef idx="2">
-            <a:schemeClr val="accent1"/>
-          </a:effectRef>
-          <a:fontRef idx="minor">
-            <a:schemeClr val="lt1"/>
-          </a:fontRef>
-        </p:style>
-        <p:txBody>
-          <a:bodyPr rtlCol="0" anchor="ctr" lIns="0" rIns="0" tIns="0" bIns="0"/>
-          <a:lstStyle/>
-          <a:p>
-            <a:pPr algn="ctr"/>
-            <a:r>
-              <a:rPr sz="1300" b="1">
-                <a:solidFill>
-                  <a:srgbClr val="21295C"/>
-                </a:solidFill>
-                <a:latin typeface="Calibri"/>
-              </a:rPr>
-              <a:t>1</a:t>
-            </a:r>
-          </a:p>
-        </p:txBody>
-      </p:sp>
-      <p:sp>
-        <p:nvSpPr>
-          <p:cNvPr id="21" name="Right Arrow 20"/>
-          <p:cNvSpPr/>
-          <p:nvPr/>
-        </p:nvSpPr>
-        <p:spPr>
-          <a:xfrm>
-            <a:off x="4059935" y="5084064"/>
-            <a:ext cx="292608" cy="256032"/>
-          </a:xfrm>
-          <a:prstGeom prst="rightArrow">
-            <a:avLst/>
-          </a:prstGeom>
-          <a:solidFill>
-            <a:srgbClr val="02C39A"/>
-          </a:solidFill>
-          <a:ln>
-            <a:noFill/>
-          </a:ln>
-          <a:effectLst/>
-        </p:spPr>
-        <p:style>
-          <a:lnRef idx="1">
-            <a:schemeClr val="accent1"/>
-          </a:lnRef>
-          <a:fillRef idx="3">
-            <a:schemeClr val="accent1"/>
-          </a:fillRef>
-          <a:effectRef idx="2">
-            <a:schemeClr val="accent1"/>
-          </a:effectRef>
-          <a:fontRef idx="minor">
-            <a:schemeClr val="lt1"/>
-          </a:fontRef>
-        </p:style>
-        <p:txBody>
-          <a:bodyPr rtlCol="0" anchor="ctr"/>
-          <a:lstStyle/>
-          <a:p>
-            <a:pPr algn="ctr"/>
-          </a:p>
-        </p:txBody>
-      </p:sp>
-      <p:sp>
-        <p:nvSpPr>
-          <p:cNvPr id="22" name="Rounded Rectangle 21"/>
-          <p:cNvSpPr/>
-          <p:nvPr/>
-        </p:nvSpPr>
-        <p:spPr>
-          <a:xfrm>
-            <a:off x="4407408" y="4526280"/>
-            <a:ext cx="3364992" cy="1371600"/>
-          </a:xfrm>
-          <a:prstGeom prst="roundRect">
-            <a:avLst>
-              <a:gd name="adj" fmla="val 6000"/>
-            </a:avLst>
-          </a:prstGeom>
-          <a:solidFill>
-            <a:srgbClr val="21295C"/>
-          </a:solidFill>
-          <a:ln>
-            <a:noFill/>
-          </a:ln>
-          <a:effectLst/>
-        </p:spPr>
-        <p:style>
-          <a:lnRef idx="1">
-            <a:schemeClr val="accent1"/>
-          </a:lnRef>
-          <a:fillRef idx="3">
-            <a:schemeClr val="accent1"/>
-          </a:fillRef>
-          <a:effectRef idx="2">
-            <a:schemeClr val="accent1"/>
-          </a:effectRef>
-          <a:fontRef idx="minor">
-            <a:schemeClr val="lt1"/>
-          </a:fontRef>
-        </p:style>
-        <p:txBody>
-          <a:bodyPr rtlCol="0" anchor="ctr" wrap="square" lIns="182880" rIns="182880" tIns="137160" bIns="137160"/>
-          <a:lstStyle/>
-          <a:p>
-            <a:pPr algn="l">
-              <a:spcAft>
-                <a:spcPts val="500"/>
-              </a:spcAft>
-            </a:pPr>
-            <a:r>
-              <a:rPr sz="1450" b="1" i="0">
-                <a:solidFill>
-                  <a:srgbClr val="FFFFFF"/>
-                </a:solidFill>
-                <a:latin typeface="Cambria"/>
-              </a:rPr>
-              <a:t>Publish</a:t>
-            </a:r>
-          </a:p>
-          <a:p>
-            <a:pPr algn="l">
-              <a:lnSpc>
-                <a:spcPct val="110000"/>
-              </a:lnSpc>
-              <a:spcAft>
-                <a:spcPts val="0"/>
-              </a:spcAft>
-            </a:pPr>
-            <a:r>
-              <a:rPr sz="1150" b="0" i="0">
-                <a:solidFill>
-                  <a:srgbClr val="C5D5E0"/>
-                </a:solidFill>
-                <a:latin typeface="Calibri"/>
-              </a:rPr>
-              <a:t>Both images pushed to GHCR, tagged with the commit SHA</a:t>
-            </a:r>
-          </a:p>
-        </p:txBody>
-      </p:sp>
-      <p:sp>
-        <p:nvSpPr>
-          <p:cNvPr id="23" name="Oval 22"/>
-          <p:cNvSpPr/>
-          <p:nvPr/>
-        </p:nvSpPr>
-        <p:spPr>
-          <a:xfrm>
-            <a:off x="7269480" y="4306824"/>
-            <a:ext cx="420624" cy="420624"/>
-          </a:xfrm>
-          <a:prstGeom prst="ellipse">
-            <a:avLst/>
-          </a:prstGeom>
-          <a:solidFill>
-            <a:srgbClr val="02C39A"/>
-          </a:solidFill>
-          <a:ln>
-            <a:noFill/>
-          </a:ln>
-          <a:effectLst/>
-        </p:spPr>
-        <p:style>
-          <a:lnRef idx="1">
-            <a:schemeClr val="accent1"/>
-          </a:lnRef>
-          <a:fillRef idx="3">
-            <a:schemeClr val="accent1"/>
-          </a:fillRef>
-          <a:effectRef idx="2">
-            <a:schemeClr val="accent1"/>
-          </a:effectRef>
-          <a:fontRef idx="minor">
-            <a:schemeClr val="lt1"/>
-          </a:fontRef>
-        </p:style>
-        <p:txBody>
-          <a:bodyPr rtlCol="0" anchor="ctr" lIns="0" rIns="0" tIns="0" bIns="0"/>
-          <a:lstStyle/>
-          <a:p>
-            <a:pPr algn="ctr"/>
-            <a:r>
-              <a:rPr sz="1300" b="1">
-                <a:solidFill>
-                  <a:srgbClr val="21295C"/>
-                </a:solidFill>
-                <a:latin typeface="Calibri"/>
-              </a:rPr>
-              <a:t>2</a:t>
-            </a:r>
-          </a:p>
-        </p:txBody>
-      </p:sp>
-      <p:sp>
-        <p:nvSpPr>
-          <p:cNvPr id="24" name="Right Arrow 23"/>
-          <p:cNvSpPr/>
-          <p:nvPr/>
-        </p:nvSpPr>
-        <p:spPr>
-          <a:xfrm>
-            <a:off x="7827264" y="5084064"/>
-            <a:ext cx="292608" cy="256032"/>
-          </a:xfrm>
-          <a:prstGeom prst="rightArrow">
-            <a:avLst/>
-          </a:prstGeom>
-          <a:solidFill>
-            <a:srgbClr val="02C39A"/>
-          </a:solidFill>
-          <a:ln>
-            <a:noFill/>
-          </a:ln>
-          <a:effectLst/>
-        </p:spPr>
-        <p:style>
-          <a:lnRef idx="1">
-            <a:schemeClr val="accent1"/>
-          </a:lnRef>
-          <a:fillRef idx="3">
-            <a:schemeClr val="accent1"/>
-          </a:fillRef>
-          <a:effectRef idx="2">
-            <a:schemeClr val="accent1"/>
-          </a:effectRef>
-          <a:fontRef idx="minor">
-            <a:schemeClr val="lt1"/>
-          </a:fontRef>
-        </p:style>
-        <p:txBody>
-          <a:bodyPr rtlCol="0" anchor="ctr"/>
-          <a:lstStyle/>
-          <a:p>
-            <a:pPr algn="ctr"/>
-          </a:p>
-        </p:txBody>
-      </p:sp>
-      <p:sp>
-        <p:nvSpPr>
-          <p:cNvPr id="25" name="Rounded Rectangle 24"/>
-          <p:cNvSpPr/>
-          <p:nvPr/>
-        </p:nvSpPr>
-        <p:spPr>
-          <a:xfrm>
-            <a:off x="8174736" y="4526280"/>
-            <a:ext cx="3364992" cy="1371600"/>
-          </a:xfrm>
-          <a:prstGeom prst="roundRect">
-            <a:avLst>
-              <a:gd name="adj" fmla="val 6000"/>
-            </a:avLst>
-          </a:prstGeom>
-          <a:solidFill>
-            <a:srgbClr val="21295C"/>
-          </a:solidFill>
-          <a:ln>
-            <a:noFill/>
-          </a:ln>
-          <a:effectLst/>
-        </p:spPr>
-        <p:style>
-          <a:lnRef idx="1">
-            <a:schemeClr val="accent1"/>
-          </a:lnRef>
-          <a:fillRef idx="3">
-            <a:schemeClr val="accent1"/>
-          </a:fillRef>
-          <a:effectRef idx="2">
-            <a:schemeClr val="accent1"/>
-          </a:effectRef>
-          <a:fontRef idx="minor">
-            <a:schemeClr val="lt1"/>
-          </a:fontRef>
-        </p:style>
-        <p:txBody>
-          <a:bodyPr rtlCol="0" anchor="ctr" wrap="square" lIns="182880" rIns="182880" tIns="137160" bIns="137160"/>
-          <a:lstStyle/>
-          <a:p>
-            <a:pPr algn="l">
-              <a:spcAft>
-                <a:spcPts val="500"/>
-              </a:spcAft>
-            </a:pPr>
-            <a:r>
-              <a:rPr sz="1450" b="1" i="0">
-                <a:solidFill>
-                  <a:srgbClr val="FFFFFF"/>
-                </a:solidFill>
-                <a:latin typeface="Cambria"/>
-              </a:rPr>
-              <a:t>Deploy</a:t>
-            </a:r>
-          </a:p>
-          <a:p>
-            <a:pPr algn="l">
-              <a:lnSpc>
-                <a:spcPct val="110000"/>
-              </a:lnSpc>
-              <a:spcAft>
-                <a:spcPts val="0"/>
-              </a:spcAft>
-            </a:pPr>
-            <a:r>
-              <a:rPr sz="1150" b="0" i="0">
-                <a:solidFill>
-                  <a:srgbClr val="C5D5E0"/>
-                </a:solidFill>
-                <a:latin typeface="Calibri"/>
-              </a:rPr>
-              <a:t>Behind an approval gate, then verifies /api/health</a:t>
-            </a:r>
-          </a:p>
-        </p:txBody>
-      </p:sp>
-      <p:sp>
-        <p:nvSpPr>
-          <p:cNvPr id="26" name="Oval 25"/>
-          <p:cNvSpPr/>
-          <p:nvPr/>
-        </p:nvSpPr>
-        <p:spPr>
-          <a:xfrm>
-            <a:off x="11036808" y="4306824"/>
-            <a:ext cx="420624" cy="420624"/>
-          </a:xfrm>
-          <a:prstGeom prst="ellipse">
-            <a:avLst/>
-          </a:prstGeom>
-          <a:solidFill>
-            <a:srgbClr val="02C39A"/>
-          </a:solidFill>
-          <a:ln>
-            <a:noFill/>
-          </a:ln>
-          <a:effectLst/>
-        </p:spPr>
-        <p:style>
-          <a:lnRef idx="1">
-            <a:schemeClr val="accent1"/>
-          </a:lnRef>
-          <a:fillRef idx="3">
-            <a:schemeClr val="accent1"/>
-          </a:fillRef>
-          <a:effectRef idx="2">
-            <a:schemeClr val="accent1"/>
-          </a:effectRef>
-          <a:fontRef idx="minor">
-            <a:schemeClr val="lt1"/>
-          </a:fontRef>
-        </p:style>
-        <p:txBody>
-          <a:bodyPr rtlCol="0" anchor="ctr" lIns="0" rIns="0" tIns="0" bIns="0"/>
-          <a:lstStyle/>
-          <a:p>
-            <a:pPr algn="ctr"/>
-            <a:r>
-              <a:rPr sz="1300" b="1">
-                <a:solidFill>
-                  <a:srgbClr val="21295C"/>
-                </a:solidFill>
-                <a:latin typeface="Calibri"/>
-              </a:rPr>
-              <a:t>3</a:t>
-            </a:r>
-          </a:p>
-        </p:txBody>
-      </p:sp>
-      <p:sp>
-        <p:nvSpPr>
-          <p:cNvPr id="27" name="TextBox 26"/>
+              <a:t>approval required</a:t>
+            </a:r>
+          </a:p>
+        </p:txBody>
+      </p:sp>
+      <p:sp>
+        <p:nvSpPr>
+          <p:cNvPr id="40" name="TextBox 39"/>
           <p:cNvSpPr txBox="1"/>
           <p:nvPr/>
         </p:nvSpPr>
         <p:spPr>
           <a:xfrm>
-            <a:off x="640080" y="6007608"/>
+            <a:off x="640080" y="5943600"/>
             <a:ext cx="10881360" cy="274320"/>
           </a:xfrm>
           <a:prstGeom prst="rect">
@@ -5623,13 +5702,13 @@
               </a:spcAft>
             </a:pPr>
             <a:r>
-              <a:rPr sz="1250" b="0" i="1">
+              <a:rPr sz="1300" b="0" i="1">
                 <a:solidFill>
                   <a:srgbClr val="5C6B7A"/>
                 </a:solidFill>
                 <a:latin typeface="Calibri"/>
               </a:rPr>
-              <a:t>Tagging each image with its commit SHA is what makes a rollback one command instead of guesswork.</a:t>
+              <a:t>A failing test turns the pull request red — it cannot be merged.</a:t>
             </a:r>
           </a:p>
         </p:txBody>
@@ -5669,7 +5748,7 @@
         <p:spPr>
           <a:xfrm>
             <a:off x="640080" y="256032"/>
-            <a:ext cx="5486400" cy="219456"/>
+            <a:ext cx="6858000" cy="219456"/>
           </a:xfrm>
           <a:prstGeom prst="rect">
             <a:avLst/>
@@ -5694,7 +5773,7 @@
                 </a:solidFill>
                 <a:latin typeface="Calibri"/>
               </a:rPr>
-              <a:t>CURRENT PROGRESS</a:t>
+              <a:t>WHERE IT STANDS</a:t>
             </a:r>
           </a:p>
         </p:txBody>
@@ -5727,13 +5806,13 @@
               </a:spcAft>
             </a:pPr>
             <a:r>
-              <a:rPr sz="3200" b="1" i="0">
+              <a:rPr sz="3400" b="1" i="0">
                 <a:solidFill>
                   <a:srgbClr val="065A82"/>
                 </a:solidFill>
                 <a:latin typeface="Cambria"/>
               </a:rPr>
-              <a:t>Running now — and honest about the gap</a:t>
+              <a:t>Live today — except the last step</a:t>
             </a:r>
           </a:p>
         </p:txBody>
@@ -5746,7 +5825,7 @@
         </p:nvSpPr>
         <p:spPr>
           <a:xfrm>
-            <a:off x="640080" y="1051560"/>
+            <a:off x="640080" y="1060704"/>
             <a:ext cx="10545775" cy="365760"/>
           </a:xfrm>
           <a:prstGeom prst="rect">
@@ -5766,13 +5845,13 @@
               </a:spcAft>
             </a:pPr>
             <a:r>
-              <a:rPr sz="1450" b="0" i="0">
+              <a:rPr sz="1500" b="0" i="0">
                 <a:solidFill>
                   <a:srgbClr val="5C6B7A"/>
                 </a:solidFill>
                 <a:latin typeface="Calibri"/>
               </a:rPr>
-              <a:t>Two of the three release jobs already run for real on every merge to main.</a:t>
+              <a:t>Two of the three release jobs already run on every merge.</a:t>
             </a:r>
           </a:p>
         </p:txBody>
@@ -5785,8 +5864,8 @@
         </p:nvSpPr>
         <p:spPr>
           <a:xfrm>
-            <a:off x="640080" y="1737360"/>
-            <a:ext cx="5303520" cy="3246120"/>
+            <a:off x="640080" y="1783080"/>
+            <a:ext cx="5029200" cy="914400"/>
           </a:xfrm>
           <a:prstGeom prst="roundRect">
             <a:avLst>
@@ -5819,153 +5898,86 @@
           <a:bodyPr rtlCol="0" anchor="ctr" wrap="square" lIns="182880" rIns="182880" tIns="137160" bIns="137160"/>
           <a:lstStyle/>
           <a:p>
+            <a:pPr algn="ctr"/>
+          </a:p>
+        </p:txBody>
+      </p:sp>
+      <p:pic>
+        <p:nvPicPr>
+          <p:cNvPr id="6" name="Picture 5" descr="g_check.png"/>
+          <p:cNvPicPr>
+            <a:picLocks noChangeAspect="1"/>
+          </p:cNvPicPr>
+          <p:nvPr/>
+        </p:nvPicPr>
+        <p:blipFill>
+          <a:blip r:embed="rId2"/>
+          <a:stretch>
+            <a:fillRect/>
+          </a:stretch>
+        </p:blipFill>
+        <p:spPr>
+          <a:xfrm>
+            <a:off x="877824" y="2020824"/>
+            <a:ext cx="438912" cy="438912"/>
+          </a:xfrm>
+          <a:prstGeom prst="rect">
+            <a:avLst/>
+          </a:prstGeom>
+        </p:spPr>
+      </p:pic>
+      <p:sp>
+        <p:nvSpPr>
+          <p:cNvPr id="7" name="TextBox 6"/>
+          <p:cNvSpPr txBox="1"/>
+          <p:nvPr/>
+        </p:nvSpPr>
+        <p:spPr>
+          <a:xfrm>
+            <a:off x="1600200" y="2057400"/>
+            <a:ext cx="3840480" cy="457200"/>
+          </a:xfrm>
+          <a:prstGeom prst="rect">
+            <a:avLst/>
+          </a:prstGeom>
+          <a:noFill/>
+        </p:spPr>
+        <p:txBody>
+          <a:bodyPr wrap="square" lIns="0" rIns="0" tIns="0" bIns="0">
+            <a:spAutoFit/>
+          </a:bodyPr>
+          <a:lstStyle/>
+          <a:p>
             <a:pPr algn="l">
+              <a:lnSpc>
+                <a:spcPct val="105000"/>
+              </a:lnSpc>
               <a:spcAft>
-                <a:spcPts val="900"/>
+                <a:spcPts val="0"/>
               </a:spcAft>
             </a:pPr>
             <a:r>
-              <a:rPr sz="1700" b="1" i="0">
+              <a:rPr sz="1550" b="1" i="0">
                 <a:solidFill>
                   <a:srgbClr val="0B6B53"/>
                 </a:solidFill>
                 <a:latin typeface="Cambria"/>
               </a:rPr>
-              <a:t>Working today</a:t>
-            </a:r>
-          </a:p>
-          <a:p>
-            <a:pPr algn="l" marL="200025" indent="-200025">
-              <a:lnSpc>
-                <a:spcPct val="110000"/>
-              </a:lnSpc>
-              <a:spcAft>
-                <a:spcPts val="600"/>
-              </a:spcAft>
-              <a:buChar char="•"/>
-            </a:pPr>
-            <a:r>
-              <a:rPr sz="1250" b="0" i="0">
-                <a:solidFill>
-                  <a:srgbClr val="1B2233"/>
-                </a:solidFill>
-                <a:latin typeface="Calibri"/>
-              </a:rPr>
-              <a:t>CI runs automatically on every push and pull request</a:t>
-            </a:r>
-          </a:p>
-          <a:p>
-            <a:pPr algn="l" marL="200025" indent="-200025">
-              <a:lnSpc>
-                <a:spcPct val="110000"/>
-              </a:lnSpc>
-              <a:spcAft>
-                <a:spcPts val="600"/>
-              </a:spcAft>
-              <a:buChar char="•"/>
-            </a:pPr>
-            <a:r>
-              <a:rPr sz="1250" b="0" i="0">
-                <a:solidFill>
-                  <a:srgbClr val="1B2233"/>
-                </a:solidFill>
-                <a:latin typeface="Calibri"/>
-              </a:rPr>
-              <a:t>A throwaway PostgreSQL is created and seeded per run, so the API tests finally run instead of being skipped</a:t>
-            </a:r>
-          </a:p>
-          <a:p>
-            <a:pPr algn="l" marL="200025" indent="-200025">
-              <a:lnSpc>
-                <a:spcPct val="110000"/>
-              </a:lnSpc>
-              <a:spcAft>
-                <a:spcPts val="600"/>
-              </a:spcAft>
-              <a:buChar char="•"/>
-            </a:pPr>
-            <a:r>
-              <a:rPr sz="1250" b="0" i="0">
-                <a:solidFill>
-                  <a:srgbClr val="1B2233"/>
-                </a:solidFill>
-                <a:latin typeface="Calibri"/>
-              </a:rPr>
-              <a:t>A smoke test proves the API actually boots, not just that tests pass</a:t>
-            </a:r>
-          </a:p>
-          <a:p>
-            <a:pPr algn="l" marL="200025" indent="-200025">
-              <a:lnSpc>
-                <a:spcPct val="110000"/>
-              </a:lnSpc>
-              <a:spcAft>
-                <a:spcPts val="600"/>
-              </a:spcAft>
-              <a:buChar char="•"/>
-            </a:pPr>
-            <a:r>
-              <a:rPr sz="1250" b="0" i="0">
-                <a:solidFill>
-                  <a:srgbClr val="1B2233"/>
-                </a:solidFill>
-                <a:latin typeface="Calibri"/>
-              </a:rPr>
-              <a:t>Both Docker images build on every run</a:t>
-            </a:r>
-          </a:p>
-          <a:p>
-            <a:pPr algn="l" marL="200025" indent="-200025">
-              <a:lnSpc>
-                <a:spcPct val="110000"/>
-              </a:lnSpc>
-              <a:spcAft>
-                <a:spcPts val="600"/>
-              </a:spcAft>
-              <a:buChar char="•"/>
-            </a:pPr>
-            <a:r>
-              <a:rPr sz="1250" b="0" i="0">
-                <a:solidFill>
-                  <a:srgbClr val="1B2233"/>
-                </a:solidFill>
-                <a:latin typeface="Calibri"/>
-              </a:rPr>
-              <a:t>Merging to main publishes both images to GHCR, tagged with the commit SHA</a:t>
-            </a:r>
-          </a:p>
-          <a:p>
-            <a:pPr algn="l" marL="200025" indent="-200025">
-              <a:lnSpc>
-                <a:spcPct val="110000"/>
-              </a:lnSpc>
-              <a:spcAft>
-                <a:spcPts val="600"/>
-              </a:spcAft>
-              <a:buChar char="•"/>
-            </a:pPr>
-            <a:r>
-              <a:rPr sz="1250" b="0" i="0">
-                <a:solidFill>
-                  <a:srgbClr val="1B2233"/>
-                </a:solidFill>
-                <a:latin typeface="Calibri"/>
-              </a:rPr>
-              <a:t>Dependabot opens dependency PRs that CI tests automatically</a:t>
-            </a:r>
-          </a:p>
-        </p:txBody>
-      </p:sp>
-      <p:sp>
-        <p:nvSpPr>
-          <p:cNvPr id="6" name="Rounded Rectangle 5"/>
+              <a:t>CI runs on every push</a:t>
+            </a:r>
+          </a:p>
+        </p:txBody>
+      </p:sp>
+      <p:sp>
+        <p:nvSpPr>
+          <p:cNvPr id="8" name="Rounded Rectangle 7"/>
           <p:cNvSpPr/>
           <p:nvPr/>
         </p:nvSpPr>
         <p:spPr>
           <a:xfrm>
-            <a:off x="6245352" y="1737360"/>
-            <a:ext cx="5303520" cy="3246120"/>
+            <a:off x="640080" y="2798064"/>
+            <a:ext cx="5029200" cy="914400"/>
           </a:xfrm>
           <a:prstGeom prst="roundRect">
             <a:avLst>
@@ -5973,7 +5985,7 @@
             </a:avLst>
           </a:prstGeom>
           <a:solidFill>
-            <a:srgbClr val="FDF3E3"/>
+            <a:srgbClr val="E6F4EF"/>
           </a:solidFill>
           <a:ln>
             <a:noFill/>
@@ -5998,133 +6010,86 @@
           <a:bodyPr rtlCol="0" anchor="ctr" wrap="square" lIns="182880" rIns="182880" tIns="137160" bIns="137160"/>
           <a:lstStyle/>
           <a:p>
+            <a:pPr algn="ctr"/>
+          </a:p>
+        </p:txBody>
+      </p:sp>
+      <p:pic>
+        <p:nvPicPr>
+          <p:cNvPr id="9" name="Picture 8" descr="g_check.png"/>
+          <p:cNvPicPr>
+            <a:picLocks noChangeAspect="1"/>
+          </p:cNvPicPr>
+          <p:nvPr/>
+        </p:nvPicPr>
+        <p:blipFill>
+          <a:blip r:embed="rId2"/>
+          <a:stretch>
+            <a:fillRect/>
+          </a:stretch>
+        </p:blipFill>
+        <p:spPr>
+          <a:xfrm>
+            <a:off x="877824" y="3035808"/>
+            <a:ext cx="438912" cy="438912"/>
+          </a:xfrm>
+          <a:prstGeom prst="rect">
+            <a:avLst/>
+          </a:prstGeom>
+        </p:spPr>
+      </p:pic>
+      <p:sp>
+        <p:nvSpPr>
+          <p:cNvPr id="10" name="TextBox 9"/>
+          <p:cNvSpPr txBox="1"/>
+          <p:nvPr/>
+        </p:nvSpPr>
+        <p:spPr>
+          <a:xfrm>
+            <a:off x="1600200" y="3072384"/>
+            <a:ext cx="3840480" cy="457200"/>
+          </a:xfrm>
+          <a:prstGeom prst="rect">
+            <a:avLst/>
+          </a:prstGeom>
+          <a:noFill/>
+        </p:spPr>
+        <p:txBody>
+          <a:bodyPr wrap="square" lIns="0" rIns="0" tIns="0" bIns="0">
+            <a:spAutoFit/>
+          </a:bodyPr>
+          <a:lstStyle/>
+          <a:p>
             <a:pPr algn="l">
+              <a:lnSpc>
+                <a:spcPct val="105000"/>
+              </a:lnSpc>
               <a:spcAft>
-                <a:spcPts val="900"/>
+                <a:spcPts val="0"/>
               </a:spcAft>
             </a:pPr>
             <a:r>
-              <a:rPr sz="1700" b="1" i="0">
+              <a:rPr sz="1550" b="1" i="0">
                 <a:solidFill>
-                  <a:srgbClr val="9A630F"/>
+                  <a:srgbClr val="0B6B53"/>
                 </a:solidFill>
                 <a:latin typeface="Cambria"/>
               </a:rPr>
-              <a:t>Not live yet — and why</a:t>
-            </a:r>
-          </a:p>
-          <a:p>
-            <a:pPr algn="l" marL="200025" indent="-200025">
-              <a:lnSpc>
-                <a:spcPct val="110000"/>
-              </a:lnSpc>
-              <a:spcAft>
-                <a:spcPts val="600"/>
-              </a:spcAft>
-              <a:buChar char="•"/>
-            </a:pPr>
-            <a:r>
-              <a:rPr sz="1250" b="0" i="0">
-                <a:solidFill>
-                  <a:srgbClr val="1B2233"/>
-                </a:solidFill>
-                <a:latin typeface="Calibri"/>
-              </a:rPr>
-              <a:t>No hosting server is provisioned, so the deploy job has no target</a:t>
-            </a:r>
-          </a:p>
-          <a:p>
-            <a:pPr algn="l" marL="200025" indent="-200025">
-              <a:lnSpc>
-                <a:spcPct val="110000"/>
-              </a:lnSpc>
-              <a:spcAft>
-                <a:spcPts val="600"/>
-              </a:spcAft>
-              <a:buChar char="•"/>
-            </a:pPr>
-            <a:r>
-              <a:rPr sz="1250" b="0" i="0">
-                <a:solidFill>
-                  <a:srgbClr val="1B2233"/>
-                </a:solidFill>
-                <a:latin typeface="Calibri"/>
-              </a:rPr>
-              <a:t>It detects the missing secret and skips with an explanation rather than failing the pipeline</a:t>
-            </a:r>
-          </a:p>
-          <a:p>
-            <a:pPr algn="l" marL="200025" indent="-200025">
-              <a:lnSpc>
-                <a:spcPct val="110000"/>
-              </a:lnSpc>
-              <a:spcAft>
-                <a:spcPts val="600"/>
-              </a:spcAft>
-              <a:buChar char="•"/>
-            </a:pPr>
-            <a:r>
-              <a:rPr sz="1250" b="0" i="0">
-                <a:solidFill>
-                  <a:srgbClr val="1B2233"/>
-                </a:solidFill>
-                <a:latin typeface="Calibri"/>
-              </a:rPr>
-              <a:t>Adding four secrets activates deployment with no workflow edit</a:t>
-            </a:r>
-          </a:p>
-          <a:p>
-            <a:pPr algn="l" marL="200025" indent="-200025">
-              <a:lnSpc>
-                <a:spcPct val="110000"/>
-              </a:lnSpc>
-              <a:spcAft>
-                <a:spcPts val="600"/>
-              </a:spcAft>
-              <a:buChar char="•"/>
-            </a:pPr>
-            <a:r>
-              <a:rPr sz="1250" b="0" i="0">
-                <a:solidFill>
-                  <a:srgbClr val="1B2233"/>
-                </a:solidFill>
-                <a:latin typeface="Calibri"/>
-              </a:rPr>
-              <a:t>No lint stage: the frontend has no ESLint config, and a stage that passes vacuously is worse than none</a:t>
-            </a:r>
-          </a:p>
-          <a:p>
-            <a:pPr algn="l" marL="200025" indent="-200025">
-              <a:lnSpc>
-                <a:spcPct val="110000"/>
-              </a:lnSpc>
-              <a:spcAft>
-                <a:spcPts val="600"/>
-              </a:spcAft>
-              <a:buChar char="•"/>
-            </a:pPr>
-            <a:r>
-              <a:rPr sz="1250" b="0" i="0">
-                <a:solidFill>
-                  <a:srgbClr val="1B2233"/>
-                </a:solidFill>
-                <a:latin typeface="Calibri"/>
-              </a:rPr>
-              <a:t>Frontend component tests are the next thing I would add</a:t>
-            </a:r>
-          </a:p>
-        </p:txBody>
-      </p:sp>
-      <p:sp>
-        <p:nvSpPr>
-          <p:cNvPr id="7" name="Rounded Rectangle 6"/>
+              <a:t>Tests run on a real database</a:t>
+            </a:r>
+          </a:p>
+        </p:txBody>
+      </p:sp>
+      <p:sp>
+        <p:nvSpPr>
+          <p:cNvPr id="11" name="Rounded Rectangle 10"/>
           <p:cNvSpPr/>
           <p:nvPr/>
         </p:nvSpPr>
         <p:spPr>
           <a:xfrm>
-            <a:off x="640080" y="5120640"/>
-            <a:ext cx="10911535" cy="1051560"/>
+            <a:off x="640080" y="3813048"/>
+            <a:ext cx="5029200" cy="914400"/>
           </a:xfrm>
           <a:prstGeom prst="roundRect">
             <a:avLst>
@@ -6132,7 +6097,7 @@
             </a:avLst>
           </a:prstGeom>
           <a:solidFill>
-            <a:srgbClr val="21295C"/>
+            <a:srgbClr val="E6F4EF"/>
           </a:solidFill>
           <a:ln>
             <a:noFill/>
@@ -6157,13 +6122,378 @@
           <a:bodyPr rtlCol="0" anchor="ctr" wrap="square" lIns="182880" rIns="182880" tIns="137160" bIns="137160"/>
           <a:lstStyle/>
           <a:p>
+            <a:pPr algn="ctr"/>
+          </a:p>
+        </p:txBody>
+      </p:sp>
+      <p:pic>
+        <p:nvPicPr>
+          <p:cNvPr id="12" name="Picture 11" descr="g_check.png"/>
+          <p:cNvPicPr>
+            <a:picLocks noChangeAspect="1"/>
+          </p:cNvPicPr>
+          <p:nvPr/>
+        </p:nvPicPr>
+        <p:blipFill>
+          <a:blip r:embed="rId2"/>
+          <a:stretch>
+            <a:fillRect/>
+          </a:stretch>
+        </p:blipFill>
+        <p:spPr>
+          <a:xfrm>
+            <a:off x="877824" y="4050791"/>
+            <a:ext cx="438912" cy="438912"/>
+          </a:xfrm>
+          <a:prstGeom prst="rect">
+            <a:avLst/>
+          </a:prstGeom>
+        </p:spPr>
+      </p:pic>
+      <p:sp>
+        <p:nvSpPr>
+          <p:cNvPr id="13" name="TextBox 12"/>
+          <p:cNvSpPr txBox="1"/>
+          <p:nvPr/>
+        </p:nvSpPr>
+        <p:spPr>
+          <a:xfrm>
+            <a:off x="1600200" y="4087368"/>
+            <a:ext cx="3840480" cy="457200"/>
+          </a:xfrm>
+          <a:prstGeom prst="rect">
+            <a:avLst/>
+          </a:prstGeom>
+          <a:noFill/>
+        </p:spPr>
+        <p:txBody>
+          <a:bodyPr wrap="square" lIns="0" rIns="0" tIns="0" bIns="0">
+            <a:spAutoFit/>
+          </a:bodyPr>
+          <a:lstStyle/>
+          <a:p>
+            <a:pPr algn="l">
+              <a:lnSpc>
+                <a:spcPct val="105000"/>
+              </a:lnSpc>
+              <a:spcAft>
+                <a:spcPts val="0"/>
+              </a:spcAft>
+            </a:pPr>
+            <a:r>
+              <a:rPr sz="1550" b="1" i="0">
+                <a:solidFill>
+                  <a:srgbClr val="0B6B53"/>
+                </a:solidFill>
+                <a:latin typeface="Cambria"/>
+              </a:rPr>
+              <a:t>Images published on every merge</a:t>
+            </a:r>
+          </a:p>
+        </p:txBody>
+      </p:sp>
+      <p:sp>
+        <p:nvSpPr>
+          <p:cNvPr id="14" name="Rounded Rectangle 13"/>
+          <p:cNvSpPr/>
+          <p:nvPr/>
+        </p:nvSpPr>
+        <p:spPr>
+          <a:xfrm>
+            <a:off x="640080" y="4828032"/>
+            <a:ext cx="5029200" cy="914400"/>
+          </a:xfrm>
+          <a:prstGeom prst="roundRect">
+            <a:avLst>
+              <a:gd name="adj" fmla="val 6000"/>
+            </a:avLst>
+          </a:prstGeom>
+          <a:solidFill>
+            <a:srgbClr val="FDF3E3"/>
+          </a:solidFill>
+          <a:ln>
+            <a:noFill/>
+          </a:ln>
+          <a:effectLst/>
+        </p:spPr>
+        <p:style>
+          <a:lnRef idx="1">
+            <a:schemeClr val="accent1"/>
+          </a:lnRef>
+          <a:fillRef idx="3">
+            <a:schemeClr val="accent1"/>
+          </a:fillRef>
+          <a:effectRef idx="2">
+            <a:schemeClr val="accent1"/>
+          </a:effectRef>
+          <a:fontRef idx="minor">
+            <a:schemeClr val="lt1"/>
+          </a:fontRef>
+        </p:style>
+        <p:txBody>
+          <a:bodyPr rtlCol="0" anchor="ctr" wrap="square" lIns="182880" rIns="182880" tIns="137160" bIns="137160"/>
+          <a:lstStyle/>
+          <a:p>
+            <a:pPr algn="ctr"/>
+          </a:p>
+        </p:txBody>
+      </p:sp>
+      <p:pic>
+        <p:nvPicPr>
+          <p:cNvPr id="15" name="Picture 14" descr="a_pause.png"/>
+          <p:cNvPicPr>
+            <a:picLocks noChangeAspect="1"/>
+          </p:cNvPicPr>
+          <p:nvPr/>
+        </p:nvPicPr>
+        <p:blipFill>
+          <a:blip r:embed="rId3"/>
+          <a:stretch>
+            <a:fillRect/>
+          </a:stretch>
+        </p:blipFill>
+        <p:spPr>
+          <a:xfrm>
+            <a:off x="877824" y="5065776"/>
+            <a:ext cx="438912" cy="438912"/>
+          </a:xfrm>
+          <a:prstGeom prst="rect">
+            <a:avLst/>
+          </a:prstGeom>
+        </p:spPr>
+      </p:pic>
+      <p:sp>
+        <p:nvSpPr>
+          <p:cNvPr id="16" name="TextBox 15"/>
+          <p:cNvSpPr txBox="1"/>
+          <p:nvPr/>
+        </p:nvSpPr>
+        <p:spPr>
+          <a:xfrm>
+            <a:off x="1600200" y="5102352"/>
+            <a:ext cx="3840480" cy="457200"/>
+          </a:xfrm>
+          <a:prstGeom prst="rect">
+            <a:avLst/>
+          </a:prstGeom>
+          <a:noFill/>
+        </p:spPr>
+        <p:txBody>
+          <a:bodyPr wrap="square" lIns="0" rIns="0" tIns="0" bIns="0">
+            <a:spAutoFit/>
+          </a:bodyPr>
+          <a:lstStyle/>
+          <a:p>
+            <a:pPr algn="l">
+              <a:lnSpc>
+                <a:spcPct val="105000"/>
+              </a:lnSpc>
+              <a:spcAft>
+                <a:spcPts val="0"/>
+              </a:spcAft>
+            </a:pPr>
+            <a:r>
+              <a:rPr sz="1550" b="1" i="0">
+                <a:solidFill>
+                  <a:srgbClr val="9A630F"/>
+                </a:solidFill>
+                <a:latin typeface="Cambria"/>
+              </a:rPr>
+              <a:t>Deploy is waiting on a server</a:t>
+            </a:r>
+          </a:p>
+        </p:txBody>
+      </p:sp>
+      <p:pic>
+        <p:nvPicPr>
+          <p:cNvPr id="17" name="Picture 16" descr="cd_status.png"/>
+          <p:cNvPicPr>
+            <a:picLocks noChangeAspect="1"/>
+          </p:cNvPicPr>
+          <p:nvPr/>
+        </p:nvPicPr>
+        <p:blipFill>
+          <a:blip r:embed="rId4"/>
+          <a:stretch>
+            <a:fillRect/>
+          </a:stretch>
+        </p:blipFill>
+        <p:spPr>
+          <a:xfrm>
+            <a:off x="5897880" y="1874519"/>
+            <a:ext cx="5029200" cy="2078736"/>
+          </a:xfrm>
+          <a:prstGeom prst="rect">
+            <a:avLst/>
+          </a:prstGeom>
+        </p:spPr>
+      </p:pic>
+      <p:sp>
+        <p:nvSpPr>
+          <p:cNvPr id="18" name="TextBox 17"/>
+          <p:cNvSpPr txBox="1"/>
+          <p:nvPr/>
+        </p:nvSpPr>
+        <p:spPr>
+          <a:xfrm>
+            <a:off x="6021324" y="3971543"/>
+            <a:ext cx="1463040" cy="274320"/>
+          </a:xfrm>
+          <a:prstGeom prst="rect">
+            <a:avLst/>
+          </a:prstGeom>
+          <a:noFill/>
+        </p:spPr>
+        <p:txBody>
+          <a:bodyPr wrap="square" lIns="0" rIns="0" tIns="0" bIns="0">
+            <a:spAutoFit/>
+          </a:bodyPr>
+          <a:lstStyle/>
+          <a:p>
+            <a:pPr algn="ctr">
+              <a:spcAft>
+                <a:spcPts val="0"/>
+              </a:spcAft>
+            </a:pPr>
+            <a:r>
+              <a:rPr sz="1300" b="1" i="0">
+                <a:solidFill>
+                  <a:srgbClr val="5C6B7A"/>
+                </a:solidFill>
+                <a:latin typeface="Calibri"/>
+              </a:rPr>
+              <a:t>Gate</a:t>
+            </a:r>
+          </a:p>
+        </p:txBody>
+      </p:sp>
+      <p:sp>
+        <p:nvSpPr>
+          <p:cNvPr id="19" name="TextBox 18"/>
+          <p:cNvSpPr txBox="1"/>
+          <p:nvPr/>
+        </p:nvSpPr>
+        <p:spPr>
+          <a:xfrm>
+            <a:off x="7680959" y="3971543"/>
+            <a:ext cx="1463040" cy="274320"/>
+          </a:xfrm>
+          <a:prstGeom prst="rect">
+            <a:avLst/>
+          </a:prstGeom>
+          <a:noFill/>
+        </p:spPr>
+        <p:txBody>
+          <a:bodyPr wrap="square" lIns="0" rIns="0" tIns="0" bIns="0">
+            <a:spAutoFit/>
+          </a:bodyPr>
+          <a:lstStyle/>
+          <a:p>
+            <a:pPr algn="ctr">
+              <a:spcAft>
+                <a:spcPts val="0"/>
+              </a:spcAft>
+            </a:pPr>
+            <a:r>
+              <a:rPr sz="1300" b="1" i="0">
+                <a:solidFill>
+                  <a:srgbClr val="5C6B7A"/>
+                </a:solidFill>
+                <a:latin typeface="Calibri"/>
+              </a:rPr>
+              <a:t>Publish</a:t>
+            </a:r>
+          </a:p>
+        </p:txBody>
+      </p:sp>
+      <p:sp>
+        <p:nvSpPr>
+          <p:cNvPr id="20" name="TextBox 19"/>
+          <p:cNvSpPr txBox="1"/>
+          <p:nvPr/>
+        </p:nvSpPr>
+        <p:spPr>
+          <a:xfrm>
+            <a:off x="9340596" y="3971543"/>
+            <a:ext cx="1463040" cy="274320"/>
+          </a:xfrm>
+          <a:prstGeom prst="rect">
+            <a:avLst/>
+          </a:prstGeom>
+          <a:noFill/>
+        </p:spPr>
+        <p:txBody>
+          <a:bodyPr wrap="square" lIns="0" rIns="0" tIns="0" bIns="0">
+            <a:spAutoFit/>
+          </a:bodyPr>
+          <a:lstStyle/>
+          <a:p>
+            <a:pPr algn="ctr">
+              <a:spcAft>
+                <a:spcPts val="0"/>
+              </a:spcAft>
+            </a:pPr>
+            <a:r>
+              <a:rPr sz="1300" b="1" i="0">
+                <a:solidFill>
+                  <a:srgbClr val="5C6B7A"/>
+                </a:solidFill>
+                <a:latin typeface="Calibri"/>
+              </a:rPr>
+              <a:t>Deploy</a:t>
+            </a:r>
+          </a:p>
+        </p:txBody>
+      </p:sp>
+      <p:sp>
+        <p:nvSpPr>
+          <p:cNvPr id="21" name="Rounded Rectangle 20"/>
+          <p:cNvSpPr/>
+          <p:nvPr/>
+        </p:nvSpPr>
+        <p:spPr>
+          <a:xfrm>
+            <a:off x="5897880" y="4434840"/>
+            <a:ext cx="5029200" cy="1399032"/>
+          </a:xfrm>
+          <a:prstGeom prst="roundRect">
+            <a:avLst>
+              <a:gd name="adj" fmla="val 6000"/>
+            </a:avLst>
+          </a:prstGeom>
+          <a:solidFill>
+            <a:srgbClr val="21295C"/>
+          </a:solidFill>
+          <a:ln>
+            <a:noFill/>
+          </a:ln>
+          <a:effectLst/>
+        </p:spPr>
+        <p:style>
+          <a:lnRef idx="1">
+            <a:schemeClr val="accent1"/>
+          </a:lnRef>
+          <a:fillRef idx="3">
+            <a:schemeClr val="accent1"/>
+          </a:fillRef>
+          <a:effectRef idx="2">
+            <a:schemeClr val="accent1"/>
+          </a:effectRef>
+          <a:fontRef idx="minor">
+            <a:schemeClr val="lt1"/>
+          </a:fontRef>
+        </p:style>
+        <p:txBody>
+          <a:bodyPr rtlCol="0" anchor="ctr" wrap="square" lIns="182880" rIns="182880" tIns="137160" bIns="137160"/>
+          <a:lstStyle/>
+          <a:p>
             <a:pPr algn="l">
               <a:spcAft>
-                <a:spcPts val="500"/>
+                <a:spcPts val="600"/>
               </a:spcAft>
             </a:pPr>
             <a:r>
-              <a:rPr sz="1400" b="1" i="0">
+              <a:rPr sz="1350" b="1" i="0">
                 <a:solidFill>
                   <a:srgbClr val="02C39A"/>
                 </a:solidFill>
@@ -6175,59 +6505,20 @@
           <a:p>
             <a:pPr algn="l">
               <a:lnSpc>
-                <a:spcPct val="114000"/>
+                <a:spcPct val="118000"/>
               </a:lnSpc>
               <a:spcAft>
                 <a:spcPts val="0"/>
               </a:spcAft>
             </a:pPr>
             <a:r>
-              <a:rPr sz="1350" b="0" i="0">
+              <a:rPr sz="1400" b="0" i="0">
                 <a:solidFill>
                   <a:srgbClr val="FFFFFF"/>
                 </a:solidFill>
                 <a:latin typeface="Calibri"/>
               </a:rPr>
-              <a:t>“Continuous integration and continuous delivery are running. Continuous deployment is deliberately switched off behind an approval gate until we have a server and frontend tests.”</a:t>
-            </a:r>
-          </a:p>
-        </p:txBody>
-      </p:sp>
-      <p:sp>
-        <p:nvSpPr>
-          <p:cNvPr id="8" name="TextBox 7"/>
-          <p:cNvSpPr txBox="1"/>
-          <p:nvPr/>
-        </p:nvSpPr>
-        <p:spPr>
-          <a:xfrm>
-            <a:off x="640080" y="6382512"/>
-            <a:ext cx="10911535" cy="256032"/>
-          </a:xfrm>
-          <a:prstGeom prst="rect">
-            <a:avLst/>
-          </a:prstGeom>
-          <a:noFill/>
-        </p:spPr>
-        <p:txBody>
-          <a:bodyPr wrap="square" lIns="0" rIns="0" tIns="0" bIns="0">
-            <a:spAutoFit/>
-          </a:bodyPr>
-          <a:lstStyle/>
-          <a:p>
-            <a:pPr algn="l">
-              <a:spcAft>
-                <a:spcPts val="0"/>
-              </a:spcAft>
-            </a:pPr>
-            <a:r>
-              <a:rPr sz="1050" b="0" i="0">
-                <a:solidFill>
-                  <a:srgbClr val="5C6B7A"/>
-                </a:solidFill>
-                <a:latin typeface="Calibri"/>
-              </a:rPr>
-              <a:t>Full write-up: docs/CICD.md   ·   Pipelines: .github/workflows/ci.yml and cd.yml</a:t>
+              <a:t>“CI and continuous delivery are running. Deployment is switched off behind an approval gate until we have a server.”</a:t>
             </a:r>
           </a:p>
         </p:txBody>

</xml_diff>